<commit_message>
Document repository and single-seed generation
Add the private code URL to research materials and describe the verified
Git Bash workflow for generating or resuming one seeded world.
</commit_message>
<xml_diff>
--- a/research/slides/多模态电网潮流计算_项目描述与目标.pptx
+++ b/research/slides/多模态电网潮流计算_项目描述与目标.pptx
@@ -2,22 +2,22 @@
 <file path=ppt/presentation.xml><?xml version="1.0" encoding="utf-8"?>
 <p:presentation xmlns:p="http://schemas.openxmlformats.org/presentationml/2006/main">
   <p:sldMasterIdLst>
-    <p:sldMasterId xmlns:r="http://schemas.openxmlformats.org/officeDocument/2006/relationships" id="2147483648" r:id="R22f693a8afb94fed"/>
+    <p:sldMasterId xmlns:r="http://schemas.openxmlformats.org/officeDocument/2006/relationships" id="2147483648" r:id="Rd5b2e6909ba642b3"/>
   </p:sldMasterIdLst>
   <p:notesMasterIdLst>
-    <p:notesMasterId xmlns:r="http://schemas.openxmlformats.org/officeDocument/2006/relationships" r:id="R350f662cb56b4df5"/>
+    <p:notesMasterId xmlns:r="http://schemas.openxmlformats.org/officeDocument/2006/relationships" r:id="R7284d8e6bea14fd5"/>
   </p:notesMasterIdLst>
   <p:sldIdLst>
-    <p:sldId xmlns:r="http://schemas.openxmlformats.org/officeDocument/2006/relationships" id="256" r:id="R756f60fe360246d1"/>
-    <p:sldId xmlns:r="http://schemas.openxmlformats.org/officeDocument/2006/relationships" id="257" r:id="R2a82651c5ed64e6b"/>
-    <p:sldId xmlns:r="http://schemas.openxmlformats.org/officeDocument/2006/relationships" id="258" r:id="R346822ab65a943bb"/>
-    <p:sldId xmlns:r="http://schemas.openxmlformats.org/officeDocument/2006/relationships" id="259" r:id="Rb7c5e67000794136"/>
-    <p:sldId xmlns:r="http://schemas.openxmlformats.org/officeDocument/2006/relationships" id="260" r:id="R3b6ca9fa88944af8"/>
-    <p:sldId xmlns:r="http://schemas.openxmlformats.org/officeDocument/2006/relationships" id="261" r:id="R26af3d055dc94db1"/>
-    <p:sldId xmlns:r="http://schemas.openxmlformats.org/officeDocument/2006/relationships" id="262" r:id="R6e130c346c154ff7"/>
-    <p:sldId xmlns:r="http://schemas.openxmlformats.org/officeDocument/2006/relationships" id="263" r:id="R8659941cc5104c0b"/>
-    <p:sldId xmlns:r="http://schemas.openxmlformats.org/officeDocument/2006/relationships" id="264" r:id="Rd3d8a47d16534e7b"/>
-    <p:sldId xmlns:r="http://schemas.openxmlformats.org/officeDocument/2006/relationships" id="265" r:id="R1871df4bf32344a6"/>
+    <p:sldId xmlns:r="http://schemas.openxmlformats.org/officeDocument/2006/relationships" id="256" r:id="Rf5e6834f9954481d"/>
+    <p:sldId xmlns:r="http://schemas.openxmlformats.org/officeDocument/2006/relationships" id="257" r:id="R9e669a67a5504413"/>
+    <p:sldId xmlns:r="http://schemas.openxmlformats.org/officeDocument/2006/relationships" id="258" r:id="R5211532244fa4711"/>
+    <p:sldId xmlns:r="http://schemas.openxmlformats.org/officeDocument/2006/relationships" id="259" r:id="Rbe104e3ef63c40c6"/>
+    <p:sldId xmlns:r="http://schemas.openxmlformats.org/officeDocument/2006/relationships" id="260" r:id="Rf5bf9f17eca84eee"/>
+    <p:sldId xmlns:r="http://schemas.openxmlformats.org/officeDocument/2006/relationships" id="261" r:id="R337bfc24c4f74468"/>
+    <p:sldId xmlns:r="http://schemas.openxmlformats.org/officeDocument/2006/relationships" id="262" r:id="Rf5af24d055f74a9b"/>
+    <p:sldId xmlns:r="http://schemas.openxmlformats.org/officeDocument/2006/relationships" id="263" r:id="Rf45702e606b3489d"/>
+    <p:sldId xmlns:r="http://schemas.openxmlformats.org/officeDocument/2006/relationships" id="264" r:id="R0100443d85f843bb"/>
+    <p:sldId xmlns:r="http://schemas.openxmlformats.org/officeDocument/2006/relationships" id="265" r:id="Reb758eae59b94fc7"/>
   </p:sldIdLst>
   <p:sldSz cx="12192000" cy="6858000"/>
   <p:notesSz cx="6858000" cy="9144000"/>
@@ -1274,7 +1274,7 @@
   </p:cSld>
   <p:clrMap bg1="lt1" tx1="dk1" bg2="lt2" tx2="dk2" accent1="accent1" accent2="accent2" accent3="accent3" accent4="accent4" accent5="accent5" accent6="accent6" hlink="hlink" folHlink="folHlink"/>
   <p:sldLayoutIdLst>
-    <p:sldLayoutId xmlns:r="http://schemas.openxmlformats.org/officeDocument/2006/relationships" id="2147483649" r:id="Rd7f57f302ae0456c"/>
+    <p:sldLayoutId xmlns:r="http://schemas.openxmlformats.org/officeDocument/2006/relationships" id="2147483649" r:id="R5197d17545c34dc9"/>
   </p:sldLayoutIdLst>
   <p:txStyles>
     <p:titleStyle>
@@ -1829,7 +1829,7 @@
           <p:nvPr/>
         </p:nvPicPr>
         <p:blipFill>
-          <a:blip xmlns:r="http://schemas.openxmlformats.org/officeDocument/2006/relationships" xmlns:a="http://schemas.openxmlformats.org/drawingml/2006/main" r:embed="R80a3d256efba469e"/>
+          <a:blip xmlns:r="http://schemas.openxmlformats.org/officeDocument/2006/relationships" xmlns:a="http://schemas.openxmlformats.org/drawingml/2006/main" r:embed="Rb1df01c103c34518"/>
           <a:srcRect xmlns:a="http://schemas.openxmlformats.org/drawingml/2006/main" l="15455" t="0" r="15455" b="0"/>
           <a:stretch xmlns:a="http://schemas.openxmlformats.org/drawingml/2006/main">
             <a:fillRect l="0" t="0" r="0" b="0"/>
@@ -1850,7 +1850,7 @@
           <p:cNvPr id="2" name="">
             <a:extLst xmlns:a="http://schemas.openxmlformats.org/drawingml/2006/main">
               <a:ext uri="{FF2B5EF4-FFF2-40B4-BE49-F238E27FC236}">
-                <a16:creationId xmlns:a16="http://schemas.microsoft.com/office/drawing/2014/main" id="{7C9BDDB7-8552-40AC-8A1D-606AED1D5649}"/>
+                <a16:creationId xmlns:a16="http://schemas.microsoft.com/office/drawing/2014/main" id="{913706EF-A9E9-4A66-80BF-2B6AA00E39E3}"/>
               </a:ext>
             </a:extLst>
           </p:cNvPr>
@@ -1878,7 +1878,7 @@
           <p:cNvPr id="3" name="">
             <a:extLst xmlns:a="http://schemas.openxmlformats.org/drawingml/2006/main">
               <a:ext uri="{FF2B5EF4-FFF2-40B4-BE49-F238E27FC236}">
-                <a16:creationId xmlns:a16="http://schemas.microsoft.com/office/drawing/2014/main" id="{D54880D3-0FE3-48CF-B815-C5DEC7EE98DC}"/>
+                <a16:creationId xmlns:a16="http://schemas.microsoft.com/office/drawing/2014/main" id="{C56F0DAD-21D5-4382-B562-C6C0735F2AD4}"/>
               </a:ext>
             </a:extLst>
           </p:cNvPr>
@@ -1936,7 +1936,7 @@
           <p:cNvPr id="4" name="">
             <a:extLst xmlns:a="http://schemas.openxmlformats.org/drawingml/2006/main">
               <a:ext uri="{FF2B5EF4-FFF2-40B4-BE49-F238E27FC236}">
-                <a16:creationId xmlns:a16="http://schemas.microsoft.com/office/drawing/2014/main" id="{1E7811C9-8B74-48D8-B04F-B3D7EE68BDA0}"/>
+                <a16:creationId xmlns:a16="http://schemas.microsoft.com/office/drawing/2014/main" id="{A37E2C82-4E01-4544-95C3-A07D5DE1B2B4}"/>
               </a:ext>
             </a:extLst>
           </p:cNvPr>
@@ -1994,7 +1994,7 @@
           <p:cNvPr id="5" name="">
             <a:extLst xmlns:a="http://schemas.openxmlformats.org/drawingml/2006/main">
               <a:ext uri="{FF2B5EF4-FFF2-40B4-BE49-F238E27FC236}">
-                <a16:creationId xmlns:a16="http://schemas.microsoft.com/office/drawing/2014/main" id="{B1FADFAE-02A2-4E26-B55D-176F05E25A23}"/>
+                <a16:creationId xmlns:a16="http://schemas.microsoft.com/office/drawing/2014/main" id="{39C156E4-836B-4DAF-83D9-3E50660AB9C6}"/>
               </a:ext>
             </a:extLst>
           </p:cNvPr>
@@ -2052,7 +2052,7 @@
           <p:cNvPr id="6" name="">
             <a:extLst xmlns:a="http://schemas.openxmlformats.org/drawingml/2006/main">
               <a:ext uri="{FF2B5EF4-FFF2-40B4-BE49-F238E27FC236}">
-                <a16:creationId xmlns:a16="http://schemas.microsoft.com/office/drawing/2014/main" id="{C43AAF36-F54F-4458-830F-E09F9AD29650}"/>
+                <a16:creationId xmlns:a16="http://schemas.microsoft.com/office/drawing/2014/main" id="{06DC433F-4C45-4C5F-8809-66E2D5155F1A}"/>
               </a:ext>
             </a:extLst>
           </p:cNvPr>
@@ -2085,7 +2085,7 @@
           <p:cNvPr id="7" name="">
             <a:extLst xmlns:a="http://schemas.openxmlformats.org/drawingml/2006/main">
               <a:ext uri="{FF2B5EF4-FFF2-40B4-BE49-F238E27FC236}">
-                <a16:creationId xmlns:a16="http://schemas.microsoft.com/office/drawing/2014/main" id="{B9123D07-537C-4F7E-8030-044957525A4E}"/>
+                <a16:creationId xmlns:a16="http://schemas.microsoft.com/office/drawing/2014/main" id="{60E3DE85-48E5-45C2-BC78-AAB7E8A35905}"/>
               </a:ext>
             </a:extLst>
           </p:cNvPr>
@@ -2143,7 +2143,7 @@
           <p:cNvPr id="8" name="">
             <a:extLst xmlns:a="http://schemas.openxmlformats.org/drawingml/2006/main">
               <a:ext uri="{FF2B5EF4-FFF2-40B4-BE49-F238E27FC236}">
-                <a16:creationId xmlns:a16="http://schemas.microsoft.com/office/drawing/2014/main" id="{AFB35476-9C8B-4420-BACC-8C205E112801}"/>
+                <a16:creationId xmlns:a16="http://schemas.microsoft.com/office/drawing/2014/main" id="{AC2A99FC-583E-4762-B17B-CA36ABB462DA}"/>
               </a:ext>
             </a:extLst>
           </p:cNvPr>
@@ -2199,7 +2199,7 @@
     </p:spTree>
     <p:extLst>
       <p:ext uri="{BB962C8B-B14F-4D97-AF65-F5344CB8AC3E}">
-        <p14:creationId xmlns:p14="http://schemas.microsoft.com/office/powerpoint/2010/main" val="1700892672"/>
+        <p14:creationId xmlns:p14="http://schemas.microsoft.com/office/powerpoint/2010/main" val="287705973"/>
       </p:ext>
     </p:extLst>
   </p:cSld>
@@ -2230,7 +2230,7 @@
           <p:cNvPr id="24" name="">
             <a:extLst xmlns:a="http://schemas.openxmlformats.org/drawingml/2006/main">
               <a:ext uri="{FF2B5EF4-FFF2-40B4-BE49-F238E27FC236}">
-                <a16:creationId xmlns:a16="http://schemas.microsoft.com/office/drawing/2014/main" id="{81B3B244-B713-42EB-A23A-88409974CDB8}"/>
+                <a16:creationId xmlns:a16="http://schemas.microsoft.com/office/drawing/2014/main" id="{03B1CB94-284C-42E1-84F9-C3C822313ABF}"/>
               </a:ext>
             </a:extLst>
           </p:cNvPr>
@@ -2288,7 +2288,7 @@
           <p:cNvPr id="2" name="">
             <a:extLst xmlns:a="http://schemas.openxmlformats.org/drawingml/2006/main">
               <a:ext uri="{FF2B5EF4-FFF2-40B4-BE49-F238E27FC236}">
-                <a16:creationId xmlns:a16="http://schemas.microsoft.com/office/drawing/2014/main" id="{E9200A1F-F2C6-47A8-9A37-D4F5CDC5EC27}"/>
+                <a16:creationId xmlns:a16="http://schemas.microsoft.com/office/drawing/2014/main" id="{9EC54782-180E-4F3D-89A5-98F1D78540F6}"/>
               </a:ext>
             </a:extLst>
           </p:cNvPr>
@@ -2346,7 +2346,7 @@
           <p:cNvPr id="3" name="">
             <a:extLst xmlns:a="http://schemas.openxmlformats.org/drawingml/2006/main">
               <a:ext uri="{FF2B5EF4-FFF2-40B4-BE49-F238E27FC236}">
-                <a16:creationId xmlns:a16="http://schemas.microsoft.com/office/drawing/2014/main" id="{32D45DAA-DE83-4DB9-92CC-1C1AD96E2F64}"/>
+                <a16:creationId xmlns:a16="http://schemas.microsoft.com/office/drawing/2014/main" id="{5BF2F9B5-A07F-4EC6-9BA2-58292C8CFBC6}"/>
               </a:ext>
             </a:extLst>
           </p:cNvPr>
@@ -2404,7 +2404,7 @@
           <p:cNvPr id="4" name="">
             <a:extLst xmlns:a="http://schemas.openxmlformats.org/drawingml/2006/main">
               <a:ext uri="{FF2B5EF4-FFF2-40B4-BE49-F238E27FC236}">
-                <a16:creationId xmlns:a16="http://schemas.microsoft.com/office/drawing/2014/main" id="{3CA243EB-2798-4BB2-8346-E5FFA21F03EA}"/>
+                <a16:creationId xmlns:a16="http://schemas.microsoft.com/office/drawing/2014/main" id="{2561F17C-A245-47C0-A9AA-E2EFECFCBEF8}"/>
               </a:ext>
             </a:extLst>
           </p:cNvPr>
@@ -2437,7 +2437,7 @@
           <p:cNvPr id="5" name="">
             <a:extLst xmlns:a="http://schemas.openxmlformats.org/drawingml/2006/main">
               <a:ext uri="{FF2B5EF4-FFF2-40B4-BE49-F238E27FC236}">
-                <a16:creationId xmlns:a16="http://schemas.microsoft.com/office/drawing/2014/main" id="{6D754974-829A-4830-8BFF-070DE32B45D4}"/>
+                <a16:creationId xmlns:a16="http://schemas.microsoft.com/office/drawing/2014/main" id="{04E7A654-D5D4-49C1-9D1C-C97D63C4A732}"/>
               </a:ext>
             </a:extLst>
           </p:cNvPr>
@@ -2472,7 +2472,7 @@
           <p:cNvPr id="6" name="">
             <a:extLst xmlns:a="http://schemas.openxmlformats.org/drawingml/2006/main">
               <a:ext uri="{FF2B5EF4-FFF2-40B4-BE49-F238E27FC236}">
-                <a16:creationId xmlns:a16="http://schemas.microsoft.com/office/drawing/2014/main" id="{89DC2065-6978-4EF1-B00F-60E3142ACAB6}"/>
+                <a16:creationId xmlns:a16="http://schemas.microsoft.com/office/drawing/2014/main" id="{E9CDF33E-1599-412C-BE16-584C51E7ADA4}"/>
               </a:ext>
             </a:extLst>
           </p:cNvPr>
@@ -2505,7 +2505,7 @@
           <p:cNvPr id="7" name="">
             <a:extLst xmlns:a="http://schemas.openxmlformats.org/drawingml/2006/main">
               <a:ext uri="{FF2B5EF4-FFF2-40B4-BE49-F238E27FC236}">
-                <a16:creationId xmlns:a16="http://schemas.microsoft.com/office/drawing/2014/main" id="{4EC0902A-A838-4298-8A9A-F2BA25E80CFE}"/>
+                <a16:creationId xmlns:a16="http://schemas.microsoft.com/office/drawing/2014/main" id="{4091A1A0-C916-48C2-90FB-C9686A719AB3}"/>
               </a:ext>
             </a:extLst>
           </p:cNvPr>
@@ -2563,7 +2563,7 @@
           <p:cNvPr id="8" name="">
             <a:extLst xmlns:a="http://schemas.openxmlformats.org/drawingml/2006/main">
               <a:ext uri="{FF2B5EF4-FFF2-40B4-BE49-F238E27FC236}">
-                <a16:creationId xmlns:a16="http://schemas.microsoft.com/office/drawing/2014/main" id="{B1C966DD-929A-459D-9DCF-0F82972E03B2}"/>
+                <a16:creationId xmlns:a16="http://schemas.microsoft.com/office/drawing/2014/main" id="{80AB3C34-28FE-42F1-9AD0-4B2C2D04B288}"/>
               </a:ext>
             </a:extLst>
           </p:cNvPr>
@@ -2621,7 +2621,7 @@
           <p:cNvPr id="9" name="">
             <a:extLst xmlns:a="http://schemas.openxmlformats.org/drawingml/2006/main">
               <a:ext uri="{FF2B5EF4-FFF2-40B4-BE49-F238E27FC236}">
-                <a16:creationId xmlns:a16="http://schemas.microsoft.com/office/drawing/2014/main" id="{2ADA9DA5-8527-4502-91C0-011B30AD595D}"/>
+                <a16:creationId xmlns:a16="http://schemas.microsoft.com/office/drawing/2014/main" id="{FE58A8C6-C8D9-441B-9731-B1B5D4907A74}"/>
               </a:ext>
             </a:extLst>
           </p:cNvPr>
@@ -2656,7 +2656,7 @@
           <p:cNvPr id="10" name="">
             <a:extLst xmlns:a="http://schemas.openxmlformats.org/drawingml/2006/main">
               <a:ext uri="{FF2B5EF4-FFF2-40B4-BE49-F238E27FC236}">
-                <a16:creationId xmlns:a16="http://schemas.microsoft.com/office/drawing/2014/main" id="{F10AF7E1-7AEC-454E-B109-6F1B6D5BA528}"/>
+                <a16:creationId xmlns:a16="http://schemas.microsoft.com/office/drawing/2014/main" id="{33540D39-2936-4F46-AEAE-E288806B5CFA}"/>
               </a:ext>
             </a:extLst>
           </p:cNvPr>
@@ -2689,7 +2689,7 @@
           <p:cNvPr id="11" name="">
             <a:extLst xmlns:a="http://schemas.openxmlformats.org/drawingml/2006/main">
               <a:ext uri="{FF2B5EF4-FFF2-40B4-BE49-F238E27FC236}">
-                <a16:creationId xmlns:a16="http://schemas.microsoft.com/office/drawing/2014/main" id="{A17CF786-DF97-4F3F-A275-621266FA94F7}"/>
+                <a16:creationId xmlns:a16="http://schemas.microsoft.com/office/drawing/2014/main" id="{5CAB12AC-0204-4917-8140-0FC080089F28}"/>
               </a:ext>
             </a:extLst>
           </p:cNvPr>
@@ -2747,7 +2747,7 @@
           <p:cNvPr id="12" name="">
             <a:extLst xmlns:a="http://schemas.openxmlformats.org/drawingml/2006/main">
               <a:ext uri="{FF2B5EF4-FFF2-40B4-BE49-F238E27FC236}">
-                <a16:creationId xmlns:a16="http://schemas.microsoft.com/office/drawing/2014/main" id="{C0FCB8C3-F1C4-4DA6-8619-C89DDF6BB594}"/>
+                <a16:creationId xmlns:a16="http://schemas.microsoft.com/office/drawing/2014/main" id="{1FF7C6E2-0976-41EF-8DCA-D0894AF0626B}"/>
               </a:ext>
             </a:extLst>
           </p:cNvPr>
@@ -2805,7 +2805,7 @@
           <p:cNvPr id="13" name="">
             <a:extLst xmlns:a="http://schemas.openxmlformats.org/drawingml/2006/main">
               <a:ext uri="{FF2B5EF4-FFF2-40B4-BE49-F238E27FC236}">
-                <a16:creationId xmlns:a16="http://schemas.microsoft.com/office/drawing/2014/main" id="{6F93FAC9-F908-4A7F-A7B1-4C335BE037C8}"/>
+                <a16:creationId xmlns:a16="http://schemas.microsoft.com/office/drawing/2014/main" id="{3F452346-72B0-4307-96EC-CCED6F15813D}"/>
               </a:ext>
             </a:extLst>
           </p:cNvPr>
@@ -2840,7 +2840,7 @@
           <p:cNvPr id="14" name="">
             <a:extLst xmlns:a="http://schemas.openxmlformats.org/drawingml/2006/main">
               <a:ext uri="{FF2B5EF4-FFF2-40B4-BE49-F238E27FC236}">
-                <a16:creationId xmlns:a16="http://schemas.microsoft.com/office/drawing/2014/main" id="{4B0683BB-D560-4404-A8E8-F5BB65BC75EC}"/>
+                <a16:creationId xmlns:a16="http://schemas.microsoft.com/office/drawing/2014/main" id="{78CB3631-C11E-4F32-A9F3-3FD6038099BA}"/>
               </a:ext>
             </a:extLst>
           </p:cNvPr>
@@ -2873,7 +2873,7 @@
           <p:cNvPr id="15" name="">
             <a:extLst xmlns:a="http://schemas.openxmlformats.org/drawingml/2006/main">
               <a:ext uri="{FF2B5EF4-FFF2-40B4-BE49-F238E27FC236}">
-                <a16:creationId xmlns:a16="http://schemas.microsoft.com/office/drawing/2014/main" id="{56582A54-D026-43F7-8B66-05C2C2E5434E}"/>
+                <a16:creationId xmlns:a16="http://schemas.microsoft.com/office/drawing/2014/main" id="{1DC903A7-B3B5-49D3-AEB6-D825F3957765}"/>
               </a:ext>
             </a:extLst>
           </p:cNvPr>
@@ -2931,7 +2931,7 @@
           <p:cNvPr id="16" name="">
             <a:extLst xmlns:a="http://schemas.openxmlformats.org/drawingml/2006/main">
               <a:ext uri="{FF2B5EF4-FFF2-40B4-BE49-F238E27FC236}">
-                <a16:creationId xmlns:a16="http://schemas.microsoft.com/office/drawing/2014/main" id="{C01C388B-70F7-419B-BFDB-E7163B31E9E5}"/>
+                <a16:creationId xmlns:a16="http://schemas.microsoft.com/office/drawing/2014/main" id="{FD0F5782-7840-4FF9-84A0-A5D8DA077921}"/>
               </a:ext>
             </a:extLst>
           </p:cNvPr>
@@ -2989,7 +2989,7 @@
           <p:cNvPr id="17" name="">
             <a:extLst xmlns:a="http://schemas.openxmlformats.org/drawingml/2006/main">
               <a:ext uri="{FF2B5EF4-FFF2-40B4-BE49-F238E27FC236}">
-                <a16:creationId xmlns:a16="http://schemas.microsoft.com/office/drawing/2014/main" id="{CFDF921E-E0F0-4FDB-BA5A-31812DE913C9}"/>
+                <a16:creationId xmlns:a16="http://schemas.microsoft.com/office/drawing/2014/main" id="{A8DA787F-A99F-4AC7-BC34-694F112F1EA8}"/>
               </a:ext>
             </a:extLst>
           </p:cNvPr>
@@ -3024,7 +3024,7 @@
           <p:cNvPr id="18" name="">
             <a:extLst xmlns:a="http://schemas.openxmlformats.org/drawingml/2006/main">
               <a:ext uri="{FF2B5EF4-FFF2-40B4-BE49-F238E27FC236}">
-                <a16:creationId xmlns:a16="http://schemas.microsoft.com/office/drawing/2014/main" id="{7FFC251C-3AA1-450E-8FD5-F5ADC649A68C}"/>
+                <a16:creationId xmlns:a16="http://schemas.microsoft.com/office/drawing/2014/main" id="{A50B899D-9EFD-4C71-AFBF-70427E9F205D}"/>
               </a:ext>
             </a:extLst>
           </p:cNvPr>
@@ -3057,7 +3057,7 @@
           <p:cNvPr id="19" name="">
             <a:extLst xmlns:a="http://schemas.openxmlformats.org/drawingml/2006/main">
               <a:ext uri="{FF2B5EF4-FFF2-40B4-BE49-F238E27FC236}">
-                <a16:creationId xmlns:a16="http://schemas.microsoft.com/office/drawing/2014/main" id="{C889F073-AFC0-4300-90D2-D1B476DE9F23}"/>
+                <a16:creationId xmlns:a16="http://schemas.microsoft.com/office/drawing/2014/main" id="{A2746A29-FCC4-4301-9062-21CC975B5091}"/>
               </a:ext>
             </a:extLst>
           </p:cNvPr>
@@ -3115,7 +3115,7 @@
           <p:cNvPr id="20" name="">
             <a:extLst xmlns:a="http://schemas.openxmlformats.org/drawingml/2006/main">
               <a:ext uri="{FF2B5EF4-FFF2-40B4-BE49-F238E27FC236}">
-                <a16:creationId xmlns:a16="http://schemas.microsoft.com/office/drawing/2014/main" id="{A6FA4594-A0F9-4C3C-BB90-BCD4B0A5C6EB}"/>
+                <a16:creationId xmlns:a16="http://schemas.microsoft.com/office/drawing/2014/main" id="{61036F87-50C4-4053-891B-DDF003080F52}"/>
               </a:ext>
             </a:extLst>
           </p:cNvPr>
@@ -3173,7 +3173,7 @@
           <p:cNvPr id="21" name="">
             <a:extLst xmlns:a="http://schemas.openxmlformats.org/drawingml/2006/main">
               <a:ext uri="{FF2B5EF4-FFF2-40B4-BE49-F238E27FC236}">
-                <a16:creationId xmlns:a16="http://schemas.microsoft.com/office/drawing/2014/main" id="{31FCDA5C-E347-4EC7-8816-F113650884F6}"/>
+                <a16:creationId xmlns:a16="http://schemas.microsoft.com/office/drawing/2014/main" id="{4B02C63A-D851-4E24-97CC-EA8FDBE4C542}"/>
               </a:ext>
             </a:extLst>
           </p:cNvPr>
@@ -3208,7 +3208,7 @@
           <p:cNvPr id="22" name="">
             <a:extLst xmlns:a="http://schemas.openxmlformats.org/drawingml/2006/main">
               <a:ext uri="{FF2B5EF4-FFF2-40B4-BE49-F238E27FC236}">
-                <a16:creationId xmlns:a16="http://schemas.microsoft.com/office/drawing/2014/main" id="{03CA30D0-4BB6-419E-954F-A5DC246D9684}"/>
+                <a16:creationId xmlns:a16="http://schemas.microsoft.com/office/drawing/2014/main" id="{70250504-E6EB-45C4-BE93-FC3189EBA25A}"/>
               </a:ext>
             </a:extLst>
           </p:cNvPr>
@@ -3266,7 +3266,7 @@
           <p:cNvPr id="23" name="">
             <a:extLst xmlns:a="http://schemas.openxmlformats.org/drawingml/2006/main">
               <a:ext uri="{FF2B5EF4-FFF2-40B4-BE49-F238E27FC236}">
-                <a16:creationId xmlns:a16="http://schemas.microsoft.com/office/drawing/2014/main" id="{C1D376F0-BA1C-4211-9EC7-A4A666D95D11}"/>
+                <a16:creationId xmlns:a16="http://schemas.microsoft.com/office/drawing/2014/main" id="{BC117131-78DF-4FAB-95D3-5F6035E9FE05}"/>
               </a:ext>
             </a:extLst>
           </p:cNvPr>
@@ -3322,7 +3322,7 @@
     </p:spTree>
     <p:extLst>
       <p:ext uri="{BB962C8B-B14F-4D97-AF65-F5344CB8AC3E}">
-        <p14:creationId xmlns:p14="http://schemas.microsoft.com/office/powerpoint/2010/main" val="945344408"/>
+        <p14:creationId xmlns:p14="http://schemas.microsoft.com/office/powerpoint/2010/main" val="36427903"/>
       </p:ext>
     </p:extLst>
   </p:cSld>
@@ -3353,7 +3353,7 @@
           <p:cNvPr id="19" name="">
             <a:extLst xmlns:a="http://schemas.openxmlformats.org/drawingml/2006/main">
               <a:ext uri="{FF2B5EF4-FFF2-40B4-BE49-F238E27FC236}">
-                <a16:creationId xmlns:a16="http://schemas.microsoft.com/office/drawing/2014/main" id="{B66132D6-D67B-4CB6-9D06-7AF51AD435D6}"/>
+                <a16:creationId xmlns:a16="http://schemas.microsoft.com/office/drawing/2014/main" id="{539A1CB3-8040-49C7-BCF2-0E253E43648B}"/>
               </a:ext>
             </a:extLst>
           </p:cNvPr>
@@ -3411,7 +3411,7 @@
           <p:cNvPr id="2" name="">
             <a:extLst xmlns:a="http://schemas.openxmlformats.org/drawingml/2006/main">
               <a:ext uri="{FF2B5EF4-FFF2-40B4-BE49-F238E27FC236}">
-                <a16:creationId xmlns:a16="http://schemas.microsoft.com/office/drawing/2014/main" id="{F3B6972F-D7AD-422D-81FC-863DBCDAA493}"/>
+                <a16:creationId xmlns:a16="http://schemas.microsoft.com/office/drawing/2014/main" id="{BF9FE24E-68EF-4166-816D-26F205402CDB}"/>
               </a:ext>
             </a:extLst>
           </p:cNvPr>
@@ -3469,7 +3469,7 @@
           <p:cNvPr id="3" name="">
             <a:extLst xmlns:a="http://schemas.openxmlformats.org/drawingml/2006/main">
               <a:ext uri="{FF2B5EF4-FFF2-40B4-BE49-F238E27FC236}">
-                <a16:creationId xmlns:a16="http://schemas.microsoft.com/office/drawing/2014/main" id="{D52E0F20-FC3F-43C8-B539-D2E5003EDE57}"/>
+                <a16:creationId xmlns:a16="http://schemas.microsoft.com/office/drawing/2014/main" id="{ECDF3BBB-7068-4409-8FA6-FEF076327B45}"/>
               </a:ext>
             </a:extLst>
           </p:cNvPr>
@@ -3527,7 +3527,7 @@
           <p:cNvPr id="4" name="">
             <a:extLst xmlns:a="http://schemas.openxmlformats.org/drawingml/2006/main">
               <a:ext uri="{FF2B5EF4-FFF2-40B4-BE49-F238E27FC236}">
-                <a16:creationId xmlns:a16="http://schemas.microsoft.com/office/drawing/2014/main" id="{69F2BBCE-4360-48FD-A8AF-968A57E70CDE}"/>
+                <a16:creationId xmlns:a16="http://schemas.microsoft.com/office/drawing/2014/main" id="{548B3C80-7897-492A-BB10-9DF75A2B97F8}"/>
               </a:ext>
             </a:extLst>
           </p:cNvPr>
@@ -3560,7 +3560,7 @@
           <p:cNvPr id="5" name="">
             <a:extLst xmlns:a="http://schemas.openxmlformats.org/drawingml/2006/main">
               <a:ext uri="{FF2B5EF4-FFF2-40B4-BE49-F238E27FC236}">
-                <a16:creationId xmlns:a16="http://schemas.microsoft.com/office/drawing/2014/main" id="{BEFCDC8C-ED22-4C25-9198-84BF26005D51}"/>
+                <a16:creationId xmlns:a16="http://schemas.microsoft.com/office/drawing/2014/main" id="{FFEEDE71-D989-48DF-90B4-062E5FAD6AC4}"/>
               </a:ext>
             </a:extLst>
           </p:cNvPr>
@@ -3595,7 +3595,7 @@
           <p:cNvPr id="6" name="">
             <a:extLst xmlns:a="http://schemas.openxmlformats.org/drawingml/2006/main">
               <a:ext uri="{FF2B5EF4-FFF2-40B4-BE49-F238E27FC236}">
-                <a16:creationId xmlns:a16="http://schemas.microsoft.com/office/drawing/2014/main" id="{70296457-A1A3-4119-B7C2-9FC8D1DD5844}"/>
+                <a16:creationId xmlns:a16="http://schemas.microsoft.com/office/drawing/2014/main" id="{C2B7A0E5-B0A9-48D8-B580-FBDC9CEB7D93}"/>
               </a:ext>
             </a:extLst>
           </p:cNvPr>
@@ -3628,7 +3628,7 @@
           <p:cNvPr id="7" name="">
             <a:extLst xmlns:a="http://schemas.openxmlformats.org/drawingml/2006/main">
               <a:ext uri="{FF2B5EF4-FFF2-40B4-BE49-F238E27FC236}">
-                <a16:creationId xmlns:a16="http://schemas.microsoft.com/office/drawing/2014/main" id="{50F8E3B2-52E0-4F99-83A8-57F76C957851}"/>
+                <a16:creationId xmlns:a16="http://schemas.microsoft.com/office/drawing/2014/main" id="{184CC805-E47A-4DD3-9152-FF3FB9B8C948}"/>
               </a:ext>
             </a:extLst>
           </p:cNvPr>
@@ -3686,7 +3686,7 @@
           <p:cNvPr id="8" name="">
             <a:extLst xmlns:a="http://schemas.openxmlformats.org/drawingml/2006/main">
               <a:ext uri="{FF2B5EF4-FFF2-40B4-BE49-F238E27FC236}">
-                <a16:creationId xmlns:a16="http://schemas.microsoft.com/office/drawing/2014/main" id="{AADABDB0-3620-428C-8EA0-F606C5212F40}"/>
+                <a16:creationId xmlns:a16="http://schemas.microsoft.com/office/drawing/2014/main" id="{4651CB30-0830-4161-972F-EBF575267BCD}"/>
               </a:ext>
             </a:extLst>
           </p:cNvPr>
@@ -3790,7 +3790,7 @@
           <p:cNvPr id="9" name="">
             <a:extLst xmlns:a="http://schemas.openxmlformats.org/drawingml/2006/main">
               <a:ext uri="{FF2B5EF4-FFF2-40B4-BE49-F238E27FC236}">
-                <a16:creationId xmlns:a16="http://schemas.microsoft.com/office/drawing/2014/main" id="{66AFFD6F-EE36-4D69-890D-C42F94421DA2}"/>
+                <a16:creationId xmlns:a16="http://schemas.microsoft.com/office/drawing/2014/main" id="{29A3654A-6972-4FF5-9522-B3F2D24FA1A7}"/>
               </a:ext>
             </a:extLst>
           </p:cNvPr>
@@ -3825,7 +3825,7 @@
           <p:cNvPr id="10" name="">
             <a:extLst xmlns:a="http://schemas.openxmlformats.org/drawingml/2006/main">
               <a:ext uri="{FF2B5EF4-FFF2-40B4-BE49-F238E27FC236}">
-                <a16:creationId xmlns:a16="http://schemas.microsoft.com/office/drawing/2014/main" id="{503DB7D6-DCF9-4D02-8634-A148DCF66E6A}"/>
+                <a16:creationId xmlns:a16="http://schemas.microsoft.com/office/drawing/2014/main" id="{33D77213-CBEA-4118-9710-906E1E6D7686}"/>
               </a:ext>
             </a:extLst>
           </p:cNvPr>
@@ -3858,7 +3858,7 @@
           <p:cNvPr id="11" name="">
             <a:extLst xmlns:a="http://schemas.openxmlformats.org/drawingml/2006/main">
               <a:ext uri="{FF2B5EF4-FFF2-40B4-BE49-F238E27FC236}">
-                <a16:creationId xmlns:a16="http://schemas.microsoft.com/office/drawing/2014/main" id="{0E5FA069-BA52-421F-A601-90046DA0DA51}"/>
+                <a16:creationId xmlns:a16="http://schemas.microsoft.com/office/drawing/2014/main" id="{BFAFD597-07F8-4278-AADC-E4736191D4A3}"/>
               </a:ext>
             </a:extLst>
           </p:cNvPr>
@@ -3916,7 +3916,7 @@
           <p:cNvPr id="12" name="">
             <a:extLst xmlns:a="http://schemas.openxmlformats.org/drawingml/2006/main">
               <a:ext uri="{FF2B5EF4-FFF2-40B4-BE49-F238E27FC236}">
-                <a16:creationId xmlns:a16="http://schemas.microsoft.com/office/drawing/2014/main" id="{9B634153-7EEC-483A-9F56-7A9BD6320402}"/>
+                <a16:creationId xmlns:a16="http://schemas.microsoft.com/office/drawing/2014/main" id="{7E04F6CF-C8EF-4BF6-9B6B-DF67DD47F9A6}"/>
               </a:ext>
             </a:extLst>
           </p:cNvPr>
@@ -4020,7 +4020,7 @@
           <p:cNvPr id="13" name="">
             <a:extLst xmlns:a="http://schemas.openxmlformats.org/drawingml/2006/main">
               <a:ext uri="{FF2B5EF4-FFF2-40B4-BE49-F238E27FC236}">
-                <a16:creationId xmlns:a16="http://schemas.microsoft.com/office/drawing/2014/main" id="{33F239D4-5991-4B6E-9990-E24024B1134F}"/>
+                <a16:creationId xmlns:a16="http://schemas.microsoft.com/office/drawing/2014/main" id="{4B7B8EEA-E220-4D84-A6C3-C218DA298E18}"/>
               </a:ext>
             </a:extLst>
           </p:cNvPr>
@@ -4055,7 +4055,7 @@
           <p:cNvPr id="14" name="">
             <a:extLst xmlns:a="http://schemas.openxmlformats.org/drawingml/2006/main">
               <a:ext uri="{FF2B5EF4-FFF2-40B4-BE49-F238E27FC236}">
-                <a16:creationId xmlns:a16="http://schemas.microsoft.com/office/drawing/2014/main" id="{54AB99F1-2B41-40EF-A453-86E82A1C2B95}"/>
+                <a16:creationId xmlns:a16="http://schemas.microsoft.com/office/drawing/2014/main" id="{DA38C50C-96F3-48F6-A59A-9134ACE400D9}"/>
               </a:ext>
             </a:extLst>
           </p:cNvPr>
@@ -4088,7 +4088,7 @@
           <p:cNvPr id="15" name="">
             <a:extLst xmlns:a="http://schemas.openxmlformats.org/drawingml/2006/main">
               <a:ext uri="{FF2B5EF4-FFF2-40B4-BE49-F238E27FC236}">
-                <a16:creationId xmlns:a16="http://schemas.microsoft.com/office/drawing/2014/main" id="{5004421E-5E05-46A5-83CA-E6852C758800}"/>
+                <a16:creationId xmlns:a16="http://schemas.microsoft.com/office/drawing/2014/main" id="{8E51C251-800E-43BD-8589-80F4C3923FB5}"/>
               </a:ext>
             </a:extLst>
           </p:cNvPr>
@@ -4146,7 +4146,7 @@
           <p:cNvPr id="16" name="">
             <a:extLst xmlns:a="http://schemas.openxmlformats.org/drawingml/2006/main">
               <a:ext uri="{FF2B5EF4-FFF2-40B4-BE49-F238E27FC236}">
-                <a16:creationId xmlns:a16="http://schemas.microsoft.com/office/drawing/2014/main" id="{A5335B81-1C37-4F7C-8139-3D38092B8CEF}"/>
+                <a16:creationId xmlns:a16="http://schemas.microsoft.com/office/drawing/2014/main" id="{0298B60C-AC71-43D2-A974-3EF98218FE73}"/>
               </a:ext>
             </a:extLst>
           </p:cNvPr>
@@ -4250,7 +4250,7 @@
           <p:cNvPr id="17" name="">
             <a:extLst xmlns:a="http://schemas.openxmlformats.org/drawingml/2006/main">
               <a:ext uri="{FF2B5EF4-FFF2-40B4-BE49-F238E27FC236}">
-                <a16:creationId xmlns:a16="http://schemas.microsoft.com/office/drawing/2014/main" id="{49B8F6CE-8FEA-4E04-ADC2-2236AD2CCD3A}"/>
+                <a16:creationId xmlns:a16="http://schemas.microsoft.com/office/drawing/2014/main" id="{95E8CCB8-6FF0-43A8-B019-6526125BDC4F}"/>
               </a:ext>
             </a:extLst>
           </p:cNvPr>
@@ -4308,7 +4308,7 @@
           <p:cNvPr id="18" name="">
             <a:extLst xmlns:a="http://schemas.openxmlformats.org/drawingml/2006/main">
               <a:ext uri="{FF2B5EF4-FFF2-40B4-BE49-F238E27FC236}">
-                <a16:creationId xmlns:a16="http://schemas.microsoft.com/office/drawing/2014/main" id="{ED730627-7153-455B-873F-12458C3D2AE6}"/>
+                <a16:creationId xmlns:a16="http://schemas.microsoft.com/office/drawing/2014/main" id="{0D495F70-F896-4EC5-8A78-95665E1FE20E}"/>
               </a:ext>
             </a:extLst>
           </p:cNvPr>
@@ -4364,7 +4364,7 @@
     </p:spTree>
     <p:extLst>
       <p:ext uri="{BB962C8B-B14F-4D97-AF65-F5344CB8AC3E}">
-        <p14:creationId xmlns:p14="http://schemas.microsoft.com/office/powerpoint/2010/main" val="1334189175"/>
+        <p14:creationId xmlns:p14="http://schemas.microsoft.com/office/powerpoint/2010/main" val="1979413133"/>
       </p:ext>
     </p:extLst>
   </p:cSld>
@@ -4395,7 +4395,7 @@
           <p:cNvPr id="32" name="">
             <a:extLst xmlns:a="http://schemas.openxmlformats.org/drawingml/2006/main">
               <a:ext uri="{FF2B5EF4-FFF2-40B4-BE49-F238E27FC236}">
-                <a16:creationId xmlns:a16="http://schemas.microsoft.com/office/drawing/2014/main" id="{EF98EA89-F76C-405F-B09C-5BA21DCE5ACA}"/>
+                <a16:creationId xmlns:a16="http://schemas.microsoft.com/office/drawing/2014/main" id="{170C9504-9B09-4D8B-AF75-1906976380F6}"/>
               </a:ext>
             </a:extLst>
           </p:cNvPr>
@@ -4453,7 +4453,7 @@
           <p:cNvPr id="2" name="">
             <a:extLst xmlns:a="http://schemas.openxmlformats.org/drawingml/2006/main">
               <a:ext uri="{FF2B5EF4-FFF2-40B4-BE49-F238E27FC236}">
-                <a16:creationId xmlns:a16="http://schemas.microsoft.com/office/drawing/2014/main" id="{4CE5FB42-0457-4F72-BDB9-8CBDDC41B01B}"/>
+                <a16:creationId xmlns:a16="http://schemas.microsoft.com/office/drawing/2014/main" id="{3E39222F-87A4-4D7A-BF88-565EC9F8BD3D}"/>
               </a:ext>
             </a:extLst>
           </p:cNvPr>
@@ -4511,7 +4511,7 @@
           <p:cNvPr id="3" name="">
             <a:extLst xmlns:a="http://schemas.openxmlformats.org/drawingml/2006/main">
               <a:ext uri="{FF2B5EF4-FFF2-40B4-BE49-F238E27FC236}">
-                <a16:creationId xmlns:a16="http://schemas.microsoft.com/office/drawing/2014/main" id="{F2C574DE-6611-4DAD-A19B-0CBA996B6F22}"/>
+                <a16:creationId xmlns:a16="http://schemas.microsoft.com/office/drawing/2014/main" id="{52DA9CE4-367D-422D-A941-AC9A58C5074C}"/>
               </a:ext>
             </a:extLst>
           </p:cNvPr>
@@ -4569,7 +4569,7 @@
           <p:cNvPr id="4" name="">
             <a:extLst xmlns:a="http://schemas.openxmlformats.org/drawingml/2006/main">
               <a:ext uri="{FF2B5EF4-FFF2-40B4-BE49-F238E27FC236}">
-                <a16:creationId xmlns:a16="http://schemas.microsoft.com/office/drawing/2014/main" id="{DB475C27-5A93-4335-B646-7127269D8F1E}"/>
+                <a16:creationId xmlns:a16="http://schemas.microsoft.com/office/drawing/2014/main" id="{FBA85ACB-5CFC-44EE-8C13-FD93D99EC407}"/>
               </a:ext>
             </a:extLst>
           </p:cNvPr>
@@ -4602,7 +4602,7 @@
           <p:cNvPr id="5" name="">
             <a:extLst xmlns:a="http://schemas.openxmlformats.org/drawingml/2006/main">
               <a:ext uri="{FF2B5EF4-FFF2-40B4-BE49-F238E27FC236}">
-                <a16:creationId xmlns:a16="http://schemas.microsoft.com/office/drawing/2014/main" id="{B4E0F318-54C9-49B9-9707-689CBE0CC9C5}"/>
+                <a16:creationId xmlns:a16="http://schemas.microsoft.com/office/drawing/2014/main" id="{89207D16-48FE-45DD-8FDF-1229ED607864}"/>
               </a:ext>
             </a:extLst>
           </p:cNvPr>
@@ -4637,7 +4637,7 @@
           <p:cNvPr id="6" name="">
             <a:extLst xmlns:a="http://schemas.openxmlformats.org/drawingml/2006/main">
               <a:ext uri="{FF2B5EF4-FFF2-40B4-BE49-F238E27FC236}">
-                <a16:creationId xmlns:a16="http://schemas.microsoft.com/office/drawing/2014/main" id="{75DB2F59-5C45-4278-A859-5CB8B106FC95}"/>
+                <a16:creationId xmlns:a16="http://schemas.microsoft.com/office/drawing/2014/main" id="{D41C1CE5-D403-47B7-A56B-C4E9B7A762E7}"/>
               </a:ext>
             </a:extLst>
           </p:cNvPr>
@@ -4670,7 +4670,7 @@
           <p:cNvPr id="7" name="">
             <a:extLst xmlns:a="http://schemas.openxmlformats.org/drawingml/2006/main">
               <a:ext uri="{FF2B5EF4-FFF2-40B4-BE49-F238E27FC236}">
-                <a16:creationId xmlns:a16="http://schemas.microsoft.com/office/drawing/2014/main" id="{2C171D4F-1BF5-4B7F-9B85-F1AAD3A42D21}"/>
+                <a16:creationId xmlns:a16="http://schemas.microsoft.com/office/drawing/2014/main" id="{3C84D305-8AA2-4188-8099-14199E2EA843}"/>
               </a:ext>
             </a:extLst>
           </p:cNvPr>
@@ -4728,7 +4728,7 @@
           <p:cNvPr id="8" name="">
             <a:extLst xmlns:a="http://schemas.openxmlformats.org/drawingml/2006/main">
               <a:ext uri="{FF2B5EF4-FFF2-40B4-BE49-F238E27FC236}">
-                <a16:creationId xmlns:a16="http://schemas.microsoft.com/office/drawing/2014/main" id="{DC3BD9D3-9A18-487F-9C7E-03F9CDF404AD}"/>
+                <a16:creationId xmlns:a16="http://schemas.microsoft.com/office/drawing/2014/main" id="{BF9FE600-1343-4452-9036-F3EE1C93ACB0}"/>
               </a:ext>
             </a:extLst>
           </p:cNvPr>
@@ -4809,7 +4809,7 @@
           <p:cNvPr id="9" name="">
             <a:extLst xmlns:a="http://schemas.openxmlformats.org/drawingml/2006/main">
               <a:ext uri="{FF2B5EF4-FFF2-40B4-BE49-F238E27FC236}">
-                <a16:creationId xmlns:a16="http://schemas.microsoft.com/office/drawing/2014/main" id="{FA05A5D8-63C6-4047-B262-14C14E4F5693}"/>
+                <a16:creationId xmlns:a16="http://schemas.microsoft.com/office/drawing/2014/main" id="{9390DB86-41B4-498F-A9C7-9392BA71CC65}"/>
               </a:ext>
             </a:extLst>
           </p:cNvPr>
@@ -4842,7 +4842,7 @@
           <p:cNvPr id="10" name="">
             <a:extLst xmlns:a="http://schemas.openxmlformats.org/drawingml/2006/main">
               <a:ext uri="{FF2B5EF4-FFF2-40B4-BE49-F238E27FC236}">
-                <a16:creationId xmlns:a16="http://schemas.microsoft.com/office/drawing/2014/main" id="{34F4EE7D-2C4D-465F-B312-1EB3DAAF6B1C}"/>
+                <a16:creationId xmlns:a16="http://schemas.microsoft.com/office/drawing/2014/main" id="{A636CA62-2D61-4817-9D88-1D37FE264E16}"/>
               </a:ext>
             </a:extLst>
           </p:cNvPr>
@@ -4877,7 +4877,7 @@
           <p:cNvPr id="11" name="">
             <a:extLst xmlns:a="http://schemas.openxmlformats.org/drawingml/2006/main">
               <a:ext uri="{FF2B5EF4-FFF2-40B4-BE49-F238E27FC236}">
-                <a16:creationId xmlns:a16="http://schemas.microsoft.com/office/drawing/2014/main" id="{3680C895-29C8-4E73-B36B-A9F51230826B}"/>
+                <a16:creationId xmlns:a16="http://schemas.microsoft.com/office/drawing/2014/main" id="{CB78402B-0980-4D0F-8856-7D275059E8C0}"/>
               </a:ext>
             </a:extLst>
           </p:cNvPr>
@@ -4910,7 +4910,7 @@
           <p:cNvPr id="12" name="">
             <a:extLst xmlns:a="http://schemas.openxmlformats.org/drawingml/2006/main">
               <a:ext uri="{FF2B5EF4-FFF2-40B4-BE49-F238E27FC236}">
-                <a16:creationId xmlns:a16="http://schemas.microsoft.com/office/drawing/2014/main" id="{6795086F-2665-49A6-BC4C-6AA84A72272A}"/>
+                <a16:creationId xmlns:a16="http://schemas.microsoft.com/office/drawing/2014/main" id="{3D6CBF15-64DC-4EE1-AE9F-61F0188F571E}"/>
               </a:ext>
             </a:extLst>
           </p:cNvPr>
@@ -4968,7 +4968,7 @@
           <p:cNvPr id="13" name="">
             <a:extLst xmlns:a="http://schemas.openxmlformats.org/drawingml/2006/main">
               <a:ext uri="{FF2B5EF4-FFF2-40B4-BE49-F238E27FC236}">
-                <a16:creationId xmlns:a16="http://schemas.microsoft.com/office/drawing/2014/main" id="{88501B2F-D073-4B51-A9D3-FE52264D50A6}"/>
+                <a16:creationId xmlns:a16="http://schemas.microsoft.com/office/drawing/2014/main" id="{F9EC1AF0-2ACF-488D-AAA2-8B1DD0D3F3AC}"/>
               </a:ext>
             </a:extLst>
           </p:cNvPr>
@@ -5049,7 +5049,7 @@
           <p:cNvPr id="14" name="">
             <a:extLst xmlns:a="http://schemas.openxmlformats.org/drawingml/2006/main">
               <a:ext uri="{FF2B5EF4-FFF2-40B4-BE49-F238E27FC236}">
-                <a16:creationId xmlns:a16="http://schemas.microsoft.com/office/drawing/2014/main" id="{426BC4FF-15FD-4383-8272-558C1026BAD4}"/>
+                <a16:creationId xmlns:a16="http://schemas.microsoft.com/office/drawing/2014/main" id="{7694BC60-2C4F-4A1F-9019-E5A83D049ABB}"/>
               </a:ext>
             </a:extLst>
           </p:cNvPr>
@@ -5082,7 +5082,7 @@
           <p:cNvPr id="15" name="">
             <a:extLst xmlns:a="http://schemas.openxmlformats.org/drawingml/2006/main">
               <a:ext uri="{FF2B5EF4-FFF2-40B4-BE49-F238E27FC236}">
-                <a16:creationId xmlns:a16="http://schemas.microsoft.com/office/drawing/2014/main" id="{8DCE3DF1-B6DD-4732-8A3B-2E216CB7A85F}"/>
+                <a16:creationId xmlns:a16="http://schemas.microsoft.com/office/drawing/2014/main" id="{60699820-DFA9-4DFC-818B-68DE9BB1D49A}"/>
               </a:ext>
             </a:extLst>
           </p:cNvPr>
@@ -5117,7 +5117,7 @@
           <p:cNvPr id="16" name="">
             <a:extLst xmlns:a="http://schemas.openxmlformats.org/drawingml/2006/main">
               <a:ext uri="{FF2B5EF4-FFF2-40B4-BE49-F238E27FC236}">
-                <a16:creationId xmlns:a16="http://schemas.microsoft.com/office/drawing/2014/main" id="{7F9729AC-A9FB-4390-BC29-46E70A05641A}"/>
+                <a16:creationId xmlns:a16="http://schemas.microsoft.com/office/drawing/2014/main" id="{6FEFBCE7-4F1B-42D4-B101-025895A3D43D}"/>
               </a:ext>
             </a:extLst>
           </p:cNvPr>
@@ -5150,7 +5150,7 @@
           <p:cNvPr id="17" name="">
             <a:extLst xmlns:a="http://schemas.openxmlformats.org/drawingml/2006/main">
               <a:ext uri="{FF2B5EF4-FFF2-40B4-BE49-F238E27FC236}">
-                <a16:creationId xmlns:a16="http://schemas.microsoft.com/office/drawing/2014/main" id="{DB562B6C-9B3B-4E79-ACF7-62E793EB2E52}"/>
+                <a16:creationId xmlns:a16="http://schemas.microsoft.com/office/drawing/2014/main" id="{1520891C-716D-47B0-AECB-540ECC2C5C74}"/>
               </a:ext>
             </a:extLst>
           </p:cNvPr>
@@ -5208,7 +5208,7 @@
           <p:cNvPr id="18" name="">
             <a:extLst xmlns:a="http://schemas.openxmlformats.org/drawingml/2006/main">
               <a:ext uri="{FF2B5EF4-FFF2-40B4-BE49-F238E27FC236}">
-                <a16:creationId xmlns:a16="http://schemas.microsoft.com/office/drawing/2014/main" id="{81C2CC54-1359-44F4-963C-FE525C0703F3}"/>
+                <a16:creationId xmlns:a16="http://schemas.microsoft.com/office/drawing/2014/main" id="{BE695492-CCB4-4333-99CA-050610C61D1F}"/>
               </a:ext>
             </a:extLst>
           </p:cNvPr>
@@ -5289,7 +5289,7 @@
           <p:cNvPr id="19" name="">
             <a:extLst xmlns:a="http://schemas.openxmlformats.org/drawingml/2006/main">
               <a:ext uri="{FF2B5EF4-FFF2-40B4-BE49-F238E27FC236}">
-                <a16:creationId xmlns:a16="http://schemas.microsoft.com/office/drawing/2014/main" id="{3018C964-CBFB-4A57-894F-53D4E70FD640}"/>
+                <a16:creationId xmlns:a16="http://schemas.microsoft.com/office/drawing/2014/main" id="{DC88558E-8762-4554-B9BF-0092CF73BA2E}"/>
               </a:ext>
             </a:extLst>
           </p:cNvPr>
@@ -5322,7 +5322,7 @@
           <p:cNvPr id="20" name="">
             <a:extLst xmlns:a="http://schemas.openxmlformats.org/drawingml/2006/main">
               <a:ext uri="{FF2B5EF4-FFF2-40B4-BE49-F238E27FC236}">
-                <a16:creationId xmlns:a16="http://schemas.microsoft.com/office/drawing/2014/main" id="{859B9DDB-4DCF-4E38-B12D-5592F55966F8}"/>
+                <a16:creationId xmlns:a16="http://schemas.microsoft.com/office/drawing/2014/main" id="{26D36955-93D5-4184-AB08-4F9E6A0163F1}"/>
               </a:ext>
             </a:extLst>
           </p:cNvPr>
@@ -5357,7 +5357,7 @@
           <p:cNvPr id="21" name="">
             <a:extLst xmlns:a="http://schemas.openxmlformats.org/drawingml/2006/main">
               <a:ext uri="{FF2B5EF4-FFF2-40B4-BE49-F238E27FC236}">
-                <a16:creationId xmlns:a16="http://schemas.microsoft.com/office/drawing/2014/main" id="{F633FC43-2F5A-4F86-A2B7-0385D193BFAA}"/>
+                <a16:creationId xmlns:a16="http://schemas.microsoft.com/office/drawing/2014/main" id="{9C2F0257-685C-44F4-8B95-CDB2A02983E4}"/>
               </a:ext>
             </a:extLst>
           </p:cNvPr>
@@ -5390,7 +5390,7 @@
           <p:cNvPr id="22" name="">
             <a:extLst xmlns:a="http://schemas.openxmlformats.org/drawingml/2006/main">
               <a:ext uri="{FF2B5EF4-FFF2-40B4-BE49-F238E27FC236}">
-                <a16:creationId xmlns:a16="http://schemas.microsoft.com/office/drawing/2014/main" id="{CC39A739-AF61-4BA0-BCA9-335F25991907}"/>
+                <a16:creationId xmlns:a16="http://schemas.microsoft.com/office/drawing/2014/main" id="{5512F0BB-04FD-4D4A-9D26-2A4DD4898EBB}"/>
               </a:ext>
             </a:extLst>
           </p:cNvPr>
@@ -5448,7 +5448,7 @@
           <p:cNvPr id="23" name="">
             <a:extLst xmlns:a="http://schemas.openxmlformats.org/drawingml/2006/main">
               <a:ext uri="{FF2B5EF4-FFF2-40B4-BE49-F238E27FC236}">
-                <a16:creationId xmlns:a16="http://schemas.microsoft.com/office/drawing/2014/main" id="{0BC557BD-ED17-4295-B731-6743D7E3161E}"/>
+                <a16:creationId xmlns:a16="http://schemas.microsoft.com/office/drawing/2014/main" id="{67776095-9C61-4BF9-8CDE-3C7BA9BE3D54}"/>
               </a:ext>
             </a:extLst>
           </p:cNvPr>
@@ -5529,7 +5529,7 @@
           <p:cNvPr id="24" name="">
             <a:extLst xmlns:a="http://schemas.openxmlformats.org/drawingml/2006/main">
               <a:ext uri="{FF2B5EF4-FFF2-40B4-BE49-F238E27FC236}">
-                <a16:creationId xmlns:a16="http://schemas.microsoft.com/office/drawing/2014/main" id="{9566B5C3-74C5-4C66-8B23-782164692B62}"/>
+                <a16:creationId xmlns:a16="http://schemas.microsoft.com/office/drawing/2014/main" id="{F341125F-F8BC-4F49-B522-448563E3A16A}"/>
               </a:ext>
             </a:extLst>
           </p:cNvPr>
@@ -5562,7 +5562,7 @@
           <p:cNvPr id="25" name="">
             <a:extLst xmlns:a="http://schemas.openxmlformats.org/drawingml/2006/main">
               <a:ext uri="{FF2B5EF4-FFF2-40B4-BE49-F238E27FC236}">
-                <a16:creationId xmlns:a16="http://schemas.microsoft.com/office/drawing/2014/main" id="{B15894DA-CFD6-41C1-AC25-E35FA1CA7012}"/>
+                <a16:creationId xmlns:a16="http://schemas.microsoft.com/office/drawing/2014/main" id="{64DE5B5D-3385-41AB-8284-47B8DB64BA2C}"/>
               </a:ext>
             </a:extLst>
           </p:cNvPr>
@@ -5597,7 +5597,7 @@
           <p:cNvPr id="26" name="">
             <a:extLst xmlns:a="http://schemas.openxmlformats.org/drawingml/2006/main">
               <a:ext uri="{FF2B5EF4-FFF2-40B4-BE49-F238E27FC236}">
-                <a16:creationId xmlns:a16="http://schemas.microsoft.com/office/drawing/2014/main" id="{B3A52E38-0219-41D3-9D3E-4D55254D9180}"/>
+                <a16:creationId xmlns:a16="http://schemas.microsoft.com/office/drawing/2014/main" id="{03E5226F-356A-4AD4-81E8-C68000439AED}"/>
               </a:ext>
             </a:extLst>
           </p:cNvPr>
@@ -5630,7 +5630,7 @@
           <p:cNvPr id="27" name="">
             <a:extLst xmlns:a="http://schemas.openxmlformats.org/drawingml/2006/main">
               <a:ext uri="{FF2B5EF4-FFF2-40B4-BE49-F238E27FC236}">
-                <a16:creationId xmlns:a16="http://schemas.microsoft.com/office/drawing/2014/main" id="{DDF41065-9061-4D64-8BAB-B7FA31A21659}"/>
+                <a16:creationId xmlns:a16="http://schemas.microsoft.com/office/drawing/2014/main" id="{7CE9E2B5-A8BF-4825-AB79-BDD97DA3A5C0}"/>
               </a:ext>
             </a:extLst>
           </p:cNvPr>
@@ -5688,7 +5688,7 @@
           <p:cNvPr id="28" name="">
             <a:extLst xmlns:a="http://schemas.openxmlformats.org/drawingml/2006/main">
               <a:ext uri="{FF2B5EF4-FFF2-40B4-BE49-F238E27FC236}">
-                <a16:creationId xmlns:a16="http://schemas.microsoft.com/office/drawing/2014/main" id="{84FE4366-7F2C-4767-A32A-E595EF87378C}"/>
+                <a16:creationId xmlns:a16="http://schemas.microsoft.com/office/drawing/2014/main" id="{6D07ABBC-ECE9-4C19-91A2-97EA0AF44CEE}"/>
               </a:ext>
             </a:extLst>
           </p:cNvPr>
@@ -5769,7 +5769,7 @@
           <p:cNvPr id="29" name="">
             <a:extLst xmlns:a="http://schemas.openxmlformats.org/drawingml/2006/main">
               <a:ext uri="{FF2B5EF4-FFF2-40B4-BE49-F238E27FC236}">
-                <a16:creationId xmlns:a16="http://schemas.microsoft.com/office/drawing/2014/main" id="{832473C5-C022-4352-A684-B3C8D7747A6C}"/>
+                <a16:creationId xmlns:a16="http://schemas.microsoft.com/office/drawing/2014/main" id="{A63E314A-D548-4F68-8054-997B77A7AB25}"/>
               </a:ext>
             </a:extLst>
           </p:cNvPr>
@@ -5804,7 +5804,7 @@
           <p:cNvPr id="30" name="">
             <a:extLst xmlns:a="http://schemas.openxmlformats.org/drawingml/2006/main">
               <a:ext uri="{FF2B5EF4-FFF2-40B4-BE49-F238E27FC236}">
-                <a16:creationId xmlns:a16="http://schemas.microsoft.com/office/drawing/2014/main" id="{68972728-A5D3-44B2-8BFE-A538F5439A6E}"/>
+                <a16:creationId xmlns:a16="http://schemas.microsoft.com/office/drawing/2014/main" id="{1836503C-739C-4337-A021-AAE16CB6BDA5}"/>
               </a:ext>
             </a:extLst>
           </p:cNvPr>
@@ -5862,7 +5862,7 @@
           <p:cNvPr id="31" name="">
             <a:extLst xmlns:a="http://schemas.openxmlformats.org/drawingml/2006/main">
               <a:ext uri="{FF2B5EF4-FFF2-40B4-BE49-F238E27FC236}">
-                <a16:creationId xmlns:a16="http://schemas.microsoft.com/office/drawing/2014/main" id="{89F2E731-8819-4690-A1E2-691E348BCFAA}"/>
+                <a16:creationId xmlns:a16="http://schemas.microsoft.com/office/drawing/2014/main" id="{307B2A32-B3F4-4CBD-A1A0-6E743B05C1FF}"/>
               </a:ext>
             </a:extLst>
           </p:cNvPr>
@@ -5918,7 +5918,7 @@
     </p:spTree>
     <p:extLst>
       <p:ext uri="{BB962C8B-B14F-4D97-AF65-F5344CB8AC3E}">
-        <p14:creationId xmlns:p14="http://schemas.microsoft.com/office/powerpoint/2010/main" val="409820004"/>
+        <p14:creationId xmlns:p14="http://schemas.microsoft.com/office/powerpoint/2010/main" val="1009062321"/>
       </p:ext>
     </p:extLst>
   </p:cSld>
@@ -5946,10 +5946,10 @@
       </p:grpSpPr>
       <p:sp>
         <p:nvSpPr>
-          <p:cNvPr id="10" name="">
-            <a:extLst xmlns:a="http://schemas.openxmlformats.org/drawingml/2006/main">
-              <a:ext uri="{FF2B5EF4-FFF2-40B4-BE49-F238E27FC236}">
-                <a16:creationId xmlns:a16="http://schemas.microsoft.com/office/drawing/2014/main" id="{AEDBBF79-DD70-41C5-984F-C862908842E9}"/>
+          <p:cNvPr id="11" name="">
+            <a:extLst xmlns:a="http://schemas.openxmlformats.org/drawingml/2006/main">
+              <a:ext uri="{FF2B5EF4-FFF2-40B4-BE49-F238E27FC236}">
+                <a16:creationId xmlns:a16="http://schemas.microsoft.com/office/drawing/2014/main" id="{1D101996-2365-4304-97C7-330E226E0CC6}"/>
               </a:ext>
             </a:extLst>
           </p:cNvPr>
@@ -6007,7 +6007,7 @@
           <p:cNvPr id="2" name="">
             <a:extLst xmlns:a="http://schemas.openxmlformats.org/drawingml/2006/main">
               <a:ext uri="{FF2B5EF4-FFF2-40B4-BE49-F238E27FC236}">
-                <a16:creationId xmlns:a16="http://schemas.microsoft.com/office/drawing/2014/main" id="{D832D07D-9764-4B3E-9E56-56A191217808}"/>
+                <a16:creationId xmlns:a16="http://schemas.microsoft.com/office/drawing/2014/main" id="{4A2B1A2A-14D0-4C7A-A5BE-6A4C02D0CB61}"/>
               </a:ext>
             </a:extLst>
           </p:cNvPr>
@@ -6065,7 +6065,7 @@
           <p:cNvPr id="3" name="">
             <a:extLst xmlns:a="http://schemas.openxmlformats.org/drawingml/2006/main">
               <a:ext uri="{FF2B5EF4-FFF2-40B4-BE49-F238E27FC236}">
-                <a16:creationId xmlns:a16="http://schemas.microsoft.com/office/drawing/2014/main" id="{6C3ACFED-C559-4C2D-8CB2-947884D6061D}"/>
+                <a16:creationId xmlns:a16="http://schemas.microsoft.com/office/drawing/2014/main" id="{2073C755-4ABB-4A44-9FA0-2805BC9939D7}"/>
               </a:ext>
             </a:extLst>
           </p:cNvPr>
@@ -6123,7 +6123,7 @@
           <p:cNvPr id="4" name="">
             <a:extLst xmlns:a="http://schemas.openxmlformats.org/drawingml/2006/main">
               <a:ext uri="{FF2B5EF4-FFF2-40B4-BE49-F238E27FC236}">
-                <a16:creationId xmlns:a16="http://schemas.microsoft.com/office/drawing/2014/main" id="{2E7BF708-7944-417D-9660-807F76B498EB}"/>
+                <a16:creationId xmlns:a16="http://schemas.microsoft.com/office/drawing/2014/main" id="{94A7717D-FF4F-43F7-A25A-19AB091DBE8D}"/>
               </a:ext>
             </a:extLst>
           </p:cNvPr>
@@ -6151,28 +6151,6 @@
           </a:ln>
         </p:spPr>
       </p:sp>
-      <p:pic>
-        <p:nvPicPr>
-          <p:cNvPr id="14" name=""/>
-          <p:cNvPicPr>
-            <a:picLocks xmlns:a="http://schemas.openxmlformats.org/drawingml/2006/main" noChangeAspect="1"/>
-          </p:cNvPicPr>
-          <p:nvPr/>
-        </p:nvPicPr>
-        <p:blipFill>
-          <a:blip xmlns:r="http://schemas.openxmlformats.org/officeDocument/2006/relationships" xmlns:a="http://schemas.openxmlformats.org/drawingml/2006/main" r:embed="R0477a8efc68f404e"/>
-          <a:stretch xmlns:a="http://schemas.openxmlformats.org/drawingml/2006/main"/>
-        </p:blipFill>
-        <p:spPr>
-          <a:xfrm xmlns:a="http://schemas.openxmlformats.org/drawingml/2006/main">
-            <a:off x="955675" y="2038350"/>
-            <a:ext cx="4422775" cy="3790950"/>
-          </a:xfrm>
-          <a:prstGeom xmlns:a="http://schemas.openxmlformats.org/drawingml/2006/main" prst="rect">
-            <a:avLst/>
-          </a:prstGeom>
-        </p:spPr>
-      </p:pic>
       <p:pic>
         <p:nvPicPr>
           <p:cNvPr id="15" name=""/>
@@ -6182,11 +6160,33 @@
           <p:nvPr/>
         </p:nvPicPr>
         <p:blipFill>
-          <a:blip xmlns:r="http://schemas.openxmlformats.org/officeDocument/2006/relationships" xmlns:a="http://schemas.openxmlformats.org/drawingml/2006/main" r:embed="R92358c7a01ee4715"/>
+          <a:blip xmlns:r="http://schemas.openxmlformats.org/officeDocument/2006/relationships" xmlns:a="http://schemas.openxmlformats.org/drawingml/2006/main" r:embed="Rd007ed141f29461f"/>
           <a:stretch xmlns:a="http://schemas.openxmlformats.org/drawingml/2006/main"/>
         </p:blipFill>
         <p:spPr>
           <a:xfrm xmlns:a="http://schemas.openxmlformats.org/drawingml/2006/main">
+            <a:off x="955675" y="2038350"/>
+            <a:ext cx="4422775" cy="3790950"/>
+          </a:xfrm>
+          <a:prstGeom xmlns:a="http://schemas.openxmlformats.org/drawingml/2006/main" prst="rect">
+            <a:avLst/>
+          </a:prstGeom>
+        </p:spPr>
+      </p:pic>
+      <p:pic>
+        <p:nvPicPr>
+          <p:cNvPr id="16" name=""/>
+          <p:cNvPicPr>
+            <a:picLocks xmlns:a="http://schemas.openxmlformats.org/drawingml/2006/main" noChangeAspect="1"/>
+          </p:cNvPicPr>
+          <p:nvPr/>
+        </p:nvPicPr>
+        <p:blipFill>
+          <a:blip xmlns:r="http://schemas.openxmlformats.org/officeDocument/2006/relationships" xmlns:a="http://schemas.openxmlformats.org/drawingml/2006/main" r:embed="R668490eff8cd449c"/>
+          <a:stretch xmlns:a="http://schemas.openxmlformats.org/drawingml/2006/main"/>
+        </p:blipFill>
+        <p:spPr>
+          <a:xfrm xmlns:a="http://schemas.openxmlformats.org/drawingml/2006/main">
             <a:off x="6660621" y="2038350"/>
             <a:ext cx="4633383" cy="3790950"/>
           </a:xfrm>
@@ -6200,7 +6200,7 @@
           <p:cNvPr id="7" name="">
             <a:extLst xmlns:a="http://schemas.openxmlformats.org/drawingml/2006/main">
               <a:ext uri="{FF2B5EF4-FFF2-40B4-BE49-F238E27FC236}">
-                <a16:creationId xmlns:a16="http://schemas.microsoft.com/office/drawing/2014/main" id="{0D717DF2-93A7-4508-9302-2DEC18F8166B}"/>
+                <a16:creationId xmlns:a16="http://schemas.microsoft.com/office/drawing/2014/main" id="{31CF6F1A-0B29-42F1-BAC9-71744999EE2B}"/>
               </a:ext>
             </a:extLst>
           </p:cNvPr>
@@ -6258,7 +6258,7 @@
           <p:cNvPr id="8" name="">
             <a:extLst xmlns:a="http://schemas.openxmlformats.org/drawingml/2006/main">
               <a:ext uri="{FF2B5EF4-FFF2-40B4-BE49-F238E27FC236}">
-                <a16:creationId xmlns:a16="http://schemas.microsoft.com/office/drawing/2014/main" id="{F0AAFAE6-50F1-469F-B624-38A16C37D699}"/>
+                <a16:creationId xmlns:a16="http://schemas.microsoft.com/office/drawing/2014/main" id="{BDFBEB46-A708-4E42-AB13-448922A0F4A5}"/>
               </a:ext>
             </a:extLst>
           </p:cNvPr>
@@ -6316,19 +6316,19 @@
           <p:cNvPr id="9" name="">
             <a:extLst xmlns:a="http://schemas.openxmlformats.org/drawingml/2006/main">
               <a:ext uri="{FF2B5EF4-FFF2-40B4-BE49-F238E27FC236}">
-                <a16:creationId xmlns:a16="http://schemas.microsoft.com/office/drawing/2014/main" id="{F8A81E5D-6300-4D65-A8E6-AC6208D74236}"/>
-              </a:ext>
-            </a:extLst>
-          </p:cNvPr>
-          <p:cNvSpPr>
-            <a:spLocks xmlns:a="http://schemas.openxmlformats.org/drawingml/2006/main" noGrp="1"/>
-          </p:cNvSpPr>
-          <p:nvPr/>
-        </p:nvSpPr>
-        <p:spPr>
-          <a:xfrm xmlns:a="http://schemas.openxmlformats.org/drawingml/2006/main">
-            <a:off x="2000250" y="6334125"/>
-            <a:ext cx="8191500" cy="257175"/>
+                <a16:creationId xmlns:a16="http://schemas.microsoft.com/office/drawing/2014/main" id="{2D07E237-54A1-46AE-B289-D14A7824CE74}"/>
+              </a:ext>
+            </a:extLst>
+          </p:cNvPr>
+          <p:cNvSpPr>
+            <a:spLocks xmlns:a="http://schemas.openxmlformats.org/drawingml/2006/main" noGrp="1"/>
+          </p:cNvSpPr>
+          <p:nvPr/>
+        </p:nvSpPr>
+        <p:spPr>
+          <a:xfrm xmlns:a="http://schemas.openxmlformats.org/drawingml/2006/main">
+            <a:off x="2000250" y="6219825"/>
+            <a:ext cx="8191500" cy="228600"/>
           </a:xfrm>
           <a:prstGeom xmlns:a="http://schemas.openxmlformats.org/drawingml/2006/main" prst="rect">
             <a:avLst/>
@@ -6346,7 +6346,7 @@
           <a:lstStyle xmlns:a="http://schemas.openxmlformats.org/drawingml/2006/main"/>
           <a:p xmlns:a="http://schemas.openxmlformats.org/drawingml/2006/main">
             <a:pPr algn="ctr">
-              <a:defRPr sz="1163" b="1">
+              <a:defRPr sz="1088" b="1">
                 <a:solidFill>
                   <a:srgbClr val="2A9D8F"/>
                 </a:solidFill>
@@ -6356,7 +6356,7 @@
               </a:defRPr>
             </a:pPr>
             <a:r>
-              <a:rPr sz="1163" b="1">
+              <a:rPr sz="1088" b="1">
                 <a:solidFill>
                   <a:srgbClr val="2A9D8F"/>
                 </a:solidFill>
@@ -6365,6 +6365,64 @@
                 <a:cs typeface="Microsoft YaHei"/>
               </a:rPr>
               <a:t>64 km基准：8个城市、约120万人；128 km尺度化：约24个城市、约406万人</a:t>
+            </a:r>
+          </a:p>
+        </p:txBody>
+      </p:sp>
+      <p:sp>
+        <p:nvSpPr>
+          <p:cNvPr id="10" name="">
+            <a:extLst xmlns:a="http://schemas.openxmlformats.org/drawingml/2006/main">
+              <a:ext uri="{FF2B5EF4-FFF2-40B4-BE49-F238E27FC236}">
+                <a16:creationId xmlns:a16="http://schemas.microsoft.com/office/drawing/2014/main" id="{2D1642E8-07E3-4114-9E11-EEE91374E9D1}"/>
+              </a:ext>
+            </a:extLst>
+          </p:cNvPr>
+          <p:cNvSpPr>
+            <a:spLocks xmlns:a="http://schemas.openxmlformats.org/drawingml/2006/main" noGrp="1"/>
+          </p:cNvSpPr>
+          <p:nvPr/>
+        </p:nvSpPr>
+        <p:spPr>
+          <a:xfrm xmlns:a="http://schemas.openxmlformats.org/drawingml/2006/main">
+            <a:off x="2000250" y="6486525"/>
+            <a:ext cx="8191500" cy="190500"/>
+          </a:xfrm>
+          <a:prstGeom xmlns:a="http://schemas.openxmlformats.org/drawingml/2006/main" prst="rect">
+            <a:avLst/>
+          </a:prstGeom>
+          <a:noFill xmlns:a="http://schemas.openxmlformats.org/drawingml/2006/main"/>
+          <a:ln xmlns:a="http://schemas.openxmlformats.org/drawingml/2006/main" w="0">
+            <a:noFill/>
+            <a:prstDash val="solid"/>
+          </a:ln>
+        </p:spPr>
+        <p:txBody>
+          <a:bodyPr xmlns:a="http://schemas.openxmlformats.org/drawingml/2006/main" wrap="square" lIns="0" tIns="0" rIns="0" bIns="0" anchor="t">
+            <a:normAutofit fontScale="100000"/>
+          </a:bodyPr>
+          <a:lstStyle xmlns:a="http://schemas.openxmlformats.org/drawingml/2006/main"/>
+          <a:p xmlns:a="http://schemas.openxmlformats.org/drawingml/2006/main">
+            <a:pPr algn="ctr">
+              <a:defRPr sz="938" b="0">
+                <a:solidFill>
+                  <a:srgbClr val="2E74B5"/>
+                </a:solidFill>
+                <a:latin typeface="Microsoft YaHei"/>
+                <a:ea typeface="Microsoft YaHei"/>
+                <a:cs typeface="Microsoft YaHei"/>
+              </a:defRPr>
+            </a:pPr>
+            <a:r>
+              <a:rPr sz="938" b="0">
+                <a:solidFill>
+                  <a:srgbClr val="2E74B5"/>
+                </a:solidFill>
+                <a:latin typeface="Microsoft YaHei"/>
+                <a:ea typeface="Microsoft YaHei"/>
+                <a:cs typeface="Microsoft YaHei"/>
+              </a:rPr>
+              <a:t>代码仓库：https://github.com/Hevensh/SimGenr（私人仓库）</a:t>
             </a:r>
           </a:p>
         </p:txBody>
@@ -6372,7 +6430,7 @@
     </p:spTree>
     <p:extLst>
       <p:ext uri="{BB962C8B-B14F-4D97-AF65-F5344CB8AC3E}">
-        <p14:creationId xmlns:p14="http://schemas.microsoft.com/office/powerpoint/2010/main" val="1076806959"/>
+        <p14:creationId xmlns:p14="http://schemas.microsoft.com/office/powerpoint/2010/main" val="1399049268"/>
       </p:ext>
     </p:extLst>
   </p:cSld>
@@ -6403,7 +6461,7 @@
           <p:cNvPr id="10" name="">
             <a:extLst xmlns:a="http://schemas.openxmlformats.org/drawingml/2006/main">
               <a:ext uri="{FF2B5EF4-FFF2-40B4-BE49-F238E27FC236}">
-                <a16:creationId xmlns:a16="http://schemas.microsoft.com/office/drawing/2014/main" id="{0143CF30-12F4-4FF9-924B-47EBEC38CDF7}"/>
+                <a16:creationId xmlns:a16="http://schemas.microsoft.com/office/drawing/2014/main" id="{426C23D1-BE87-49BE-9E4E-D14C517670D5}"/>
               </a:ext>
             </a:extLst>
           </p:cNvPr>
@@ -6461,7 +6519,7 @@
           <p:cNvPr id="2" name="">
             <a:extLst xmlns:a="http://schemas.openxmlformats.org/drawingml/2006/main">
               <a:ext uri="{FF2B5EF4-FFF2-40B4-BE49-F238E27FC236}">
-                <a16:creationId xmlns:a16="http://schemas.microsoft.com/office/drawing/2014/main" id="{BD681CAA-7E17-445F-856F-5914FDCFEE5E}"/>
+                <a16:creationId xmlns:a16="http://schemas.microsoft.com/office/drawing/2014/main" id="{CA6D485D-FC8E-4E3F-B290-6838C041F65C}"/>
               </a:ext>
             </a:extLst>
           </p:cNvPr>
@@ -6519,7 +6577,7 @@
           <p:cNvPr id="3" name="">
             <a:extLst xmlns:a="http://schemas.openxmlformats.org/drawingml/2006/main">
               <a:ext uri="{FF2B5EF4-FFF2-40B4-BE49-F238E27FC236}">
-                <a16:creationId xmlns:a16="http://schemas.microsoft.com/office/drawing/2014/main" id="{C555DB30-819D-4B04-8858-4676D66B6864}"/>
+                <a16:creationId xmlns:a16="http://schemas.microsoft.com/office/drawing/2014/main" id="{0F3BC59D-89CD-403C-ADEC-F6268FEECAB5}"/>
               </a:ext>
             </a:extLst>
           </p:cNvPr>
@@ -6577,7 +6635,7 @@
           <p:cNvPr id="4" name="">
             <a:extLst xmlns:a="http://schemas.openxmlformats.org/drawingml/2006/main">
               <a:ext uri="{FF2B5EF4-FFF2-40B4-BE49-F238E27FC236}">
-                <a16:creationId xmlns:a16="http://schemas.microsoft.com/office/drawing/2014/main" id="{BD7C9B5A-1ECB-428F-99A5-F93706D23C84}"/>
+                <a16:creationId xmlns:a16="http://schemas.microsoft.com/office/drawing/2014/main" id="{F78BD964-641B-4BEE-83C7-19B2E7C110D5}"/>
               </a:ext>
             </a:extLst>
           </p:cNvPr>
@@ -6614,7 +6672,7 @@
           <p:nvPr/>
         </p:nvPicPr>
         <p:blipFill>
-          <a:blip xmlns:r="http://schemas.openxmlformats.org/officeDocument/2006/relationships" xmlns:a="http://schemas.openxmlformats.org/drawingml/2006/main" r:embed="Rc4f47a63c35b4d36"/>
+          <a:blip xmlns:r="http://schemas.openxmlformats.org/officeDocument/2006/relationships" xmlns:a="http://schemas.openxmlformats.org/drawingml/2006/main" r:embed="R0a5e774958224e7b"/>
           <a:stretch xmlns:a="http://schemas.openxmlformats.org/drawingml/2006/main"/>
         </p:blipFill>
         <p:spPr>
@@ -6636,7 +6694,7 @@
           <p:nvPr/>
         </p:nvPicPr>
         <p:blipFill>
-          <a:blip xmlns:r="http://schemas.openxmlformats.org/officeDocument/2006/relationships" xmlns:a="http://schemas.openxmlformats.org/drawingml/2006/main" r:embed="R4a1c4e1fab314b7b"/>
+          <a:blip xmlns:r="http://schemas.openxmlformats.org/officeDocument/2006/relationships" xmlns:a="http://schemas.openxmlformats.org/drawingml/2006/main" r:embed="Rad066907861f4fb6"/>
           <a:stretch xmlns:a="http://schemas.openxmlformats.org/drawingml/2006/main"/>
         </p:blipFill>
         <p:spPr>
@@ -6654,7 +6712,7 @@
           <p:cNvPr id="7" name="">
             <a:extLst xmlns:a="http://schemas.openxmlformats.org/drawingml/2006/main">
               <a:ext uri="{FF2B5EF4-FFF2-40B4-BE49-F238E27FC236}">
-                <a16:creationId xmlns:a16="http://schemas.microsoft.com/office/drawing/2014/main" id="{36787E14-48A1-485A-8E07-9709AD866E7A}"/>
+                <a16:creationId xmlns:a16="http://schemas.microsoft.com/office/drawing/2014/main" id="{94F28879-A25E-4972-9F00-E27D35DEE92A}"/>
               </a:ext>
             </a:extLst>
           </p:cNvPr>
@@ -6712,7 +6770,7 @@
           <p:cNvPr id="8" name="">
             <a:extLst xmlns:a="http://schemas.openxmlformats.org/drawingml/2006/main">
               <a:ext uri="{FF2B5EF4-FFF2-40B4-BE49-F238E27FC236}">
-                <a16:creationId xmlns:a16="http://schemas.microsoft.com/office/drawing/2014/main" id="{C93BE705-07F7-4C54-9923-4715CF9C03EB}"/>
+                <a16:creationId xmlns:a16="http://schemas.microsoft.com/office/drawing/2014/main" id="{0F9ABE7F-3532-4232-AAB5-F2AD118FB95B}"/>
               </a:ext>
             </a:extLst>
           </p:cNvPr>
@@ -6770,7 +6828,7 @@
           <p:cNvPr id="9" name="">
             <a:extLst xmlns:a="http://schemas.openxmlformats.org/drawingml/2006/main">
               <a:ext uri="{FF2B5EF4-FFF2-40B4-BE49-F238E27FC236}">
-                <a16:creationId xmlns:a16="http://schemas.microsoft.com/office/drawing/2014/main" id="{FA2F7B84-652C-40DA-A886-9D489281E5D0}"/>
+                <a16:creationId xmlns:a16="http://schemas.microsoft.com/office/drawing/2014/main" id="{F9A80E95-89FB-4056-93BE-7590B3F3DCEC}"/>
               </a:ext>
             </a:extLst>
           </p:cNvPr>
@@ -6826,7 +6884,7 @@
     </p:spTree>
     <p:extLst>
       <p:ext uri="{BB962C8B-B14F-4D97-AF65-F5344CB8AC3E}">
-        <p14:creationId xmlns:p14="http://schemas.microsoft.com/office/powerpoint/2010/main" val="1703856"/>
+        <p14:creationId xmlns:p14="http://schemas.microsoft.com/office/powerpoint/2010/main" val="952618670"/>
       </p:ext>
     </p:extLst>
   </p:cSld>
@@ -6857,7 +6915,7 @@
           <p:cNvPr id="10" name="">
             <a:extLst xmlns:a="http://schemas.openxmlformats.org/drawingml/2006/main">
               <a:ext uri="{FF2B5EF4-FFF2-40B4-BE49-F238E27FC236}">
-                <a16:creationId xmlns:a16="http://schemas.microsoft.com/office/drawing/2014/main" id="{C58DDDF1-1B39-4C20-8446-8C392DD4C733}"/>
+                <a16:creationId xmlns:a16="http://schemas.microsoft.com/office/drawing/2014/main" id="{78715B34-8323-4FF7-B525-76AA881E82CE}"/>
               </a:ext>
             </a:extLst>
           </p:cNvPr>
@@ -6915,7 +6973,7 @@
           <p:cNvPr id="2" name="">
             <a:extLst xmlns:a="http://schemas.openxmlformats.org/drawingml/2006/main">
               <a:ext uri="{FF2B5EF4-FFF2-40B4-BE49-F238E27FC236}">
-                <a16:creationId xmlns:a16="http://schemas.microsoft.com/office/drawing/2014/main" id="{379695F3-050A-42FF-9139-B5AF8FF043EA}"/>
+                <a16:creationId xmlns:a16="http://schemas.microsoft.com/office/drawing/2014/main" id="{F65BA5DD-C48E-4356-934C-64A0D57589A9}"/>
               </a:ext>
             </a:extLst>
           </p:cNvPr>
@@ -6973,7 +7031,7 @@
           <p:cNvPr id="3" name="">
             <a:extLst xmlns:a="http://schemas.openxmlformats.org/drawingml/2006/main">
               <a:ext uri="{FF2B5EF4-FFF2-40B4-BE49-F238E27FC236}">
-                <a16:creationId xmlns:a16="http://schemas.microsoft.com/office/drawing/2014/main" id="{A59F653B-2EE5-4F9C-A068-9ABC8D825A6F}"/>
+                <a16:creationId xmlns:a16="http://schemas.microsoft.com/office/drawing/2014/main" id="{1E20FF96-FFCD-4DFF-BA14-15653C353488}"/>
               </a:ext>
             </a:extLst>
           </p:cNvPr>
@@ -7031,7 +7089,7 @@
           <p:cNvPr id="4" name="">
             <a:extLst xmlns:a="http://schemas.openxmlformats.org/drawingml/2006/main">
               <a:ext uri="{FF2B5EF4-FFF2-40B4-BE49-F238E27FC236}">
-                <a16:creationId xmlns:a16="http://schemas.microsoft.com/office/drawing/2014/main" id="{71E77AF1-52A7-4C6F-9C85-8CBAD0BA8157}"/>
+                <a16:creationId xmlns:a16="http://schemas.microsoft.com/office/drawing/2014/main" id="{DC4EECB9-A7AE-4F74-8EE2-46160B8D40FF}"/>
               </a:ext>
             </a:extLst>
           </p:cNvPr>
@@ -7068,7 +7126,7 @@
           <p:nvPr/>
         </p:nvPicPr>
         <p:blipFill>
-          <a:blip xmlns:r="http://schemas.openxmlformats.org/officeDocument/2006/relationships" xmlns:a="http://schemas.openxmlformats.org/drawingml/2006/main" r:embed="R20bdba1d8c1f46f1"/>
+          <a:blip xmlns:r="http://schemas.openxmlformats.org/officeDocument/2006/relationships" xmlns:a="http://schemas.openxmlformats.org/drawingml/2006/main" r:embed="Rae2a89dd9cd94f2a"/>
           <a:stretch xmlns:a="http://schemas.openxmlformats.org/drawingml/2006/main"/>
         </p:blipFill>
         <p:spPr>
@@ -7090,7 +7148,7 @@
           <p:nvPr/>
         </p:nvPicPr>
         <p:blipFill>
-          <a:blip xmlns:r="http://schemas.openxmlformats.org/officeDocument/2006/relationships" xmlns:a="http://schemas.openxmlformats.org/drawingml/2006/main" r:embed="R9111af9ce39b4f96"/>
+          <a:blip xmlns:r="http://schemas.openxmlformats.org/officeDocument/2006/relationships" xmlns:a="http://schemas.openxmlformats.org/drawingml/2006/main" r:embed="R84f3b323b0814239"/>
           <a:stretch xmlns:a="http://schemas.openxmlformats.org/drawingml/2006/main"/>
         </p:blipFill>
         <p:spPr>
@@ -7108,7 +7166,7 @@
           <p:cNvPr id="7" name="">
             <a:extLst xmlns:a="http://schemas.openxmlformats.org/drawingml/2006/main">
               <a:ext uri="{FF2B5EF4-FFF2-40B4-BE49-F238E27FC236}">
-                <a16:creationId xmlns:a16="http://schemas.microsoft.com/office/drawing/2014/main" id="{5E5231E7-395B-4781-9142-F5B1F359341C}"/>
+                <a16:creationId xmlns:a16="http://schemas.microsoft.com/office/drawing/2014/main" id="{10499804-1E1C-444D-A316-88C3F4FC9E06}"/>
               </a:ext>
             </a:extLst>
           </p:cNvPr>
@@ -7166,7 +7224,7 @@
           <p:cNvPr id="8" name="">
             <a:extLst xmlns:a="http://schemas.openxmlformats.org/drawingml/2006/main">
               <a:ext uri="{FF2B5EF4-FFF2-40B4-BE49-F238E27FC236}">
-                <a16:creationId xmlns:a16="http://schemas.microsoft.com/office/drawing/2014/main" id="{D9882DEC-4D0F-43D9-BDF6-AF47E7EFB805}"/>
+                <a16:creationId xmlns:a16="http://schemas.microsoft.com/office/drawing/2014/main" id="{5E6C3F83-DA39-458C-B0DA-63AF83FE8C60}"/>
               </a:ext>
             </a:extLst>
           </p:cNvPr>
@@ -7224,7 +7282,7 @@
           <p:cNvPr id="9" name="">
             <a:extLst xmlns:a="http://schemas.openxmlformats.org/drawingml/2006/main">
               <a:ext uri="{FF2B5EF4-FFF2-40B4-BE49-F238E27FC236}">
-                <a16:creationId xmlns:a16="http://schemas.microsoft.com/office/drawing/2014/main" id="{CC091990-45AE-4343-B0B4-E08CC8296231}"/>
+                <a16:creationId xmlns:a16="http://schemas.microsoft.com/office/drawing/2014/main" id="{926E0A49-73EA-4697-8D75-FC6821590F09}"/>
               </a:ext>
             </a:extLst>
           </p:cNvPr>
@@ -7280,7 +7338,7 @@
     </p:spTree>
     <p:extLst>
       <p:ext uri="{BB962C8B-B14F-4D97-AF65-F5344CB8AC3E}">
-        <p14:creationId xmlns:p14="http://schemas.microsoft.com/office/powerpoint/2010/main" val="1835991129"/>
+        <p14:creationId xmlns:p14="http://schemas.microsoft.com/office/powerpoint/2010/main" val="1397600369"/>
       </p:ext>
     </p:extLst>
   </p:cSld>
@@ -7311,7 +7369,7 @@
           <p:cNvPr id="18" name="">
             <a:extLst xmlns:a="http://schemas.openxmlformats.org/drawingml/2006/main">
               <a:ext uri="{FF2B5EF4-FFF2-40B4-BE49-F238E27FC236}">
-                <a16:creationId xmlns:a16="http://schemas.microsoft.com/office/drawing/2014/main" id="{30D0E723-9B68-40CE-9767-940255567508}"/>
+                <a16:creationId xmlns:a16="http://schemas.microsoft.com/office/drawing/2014/main" id="{7B8EE6D6-4C46-4812-89F2-14F1B66E3B43}"/>
               </a:ext>
             </a:extLst>
           </p:cNvPr>
@@ -7369,7 +7427,7 @@
           <p:cNvPr id="2" name="">
             <a:extLst xmlns:a="http://schemas.openxmlformats.org/drawingml/2006/main">
               <a:ext uri="{FF2B5EF4-FFF2-40B4-BE49-F238E27FC236}">
-                <a16:creationId xmlns:a16="http://schemas.microsoft.com/office/drawing/2014/main" id="{20CBAE7F-509E-43AC-B78D-409F25C0DB0F}"/>
+                <a16:creationId xmlns:a16="http://schemas.microsoft.com/office/drawing/2014/main" id="{0E2D0983-2CFB-435B-A5F4-C17F4794A64B}"/>
               </a:ext>
             </a:extLst>
           </p:cNvPr>
@@ -7427,7 +7485,7 @@
           <p:cNvPr id="3" name="">
             <a:extLst xmlns:a="http://schemas.openxmlformats.org/drawingml/2006/main">
               <a:ext uri="{FF2B5EF4-FFF2-40B4-BE49-F238E27FC236}">
-                <a16:creationId xmlns:a16="http://schemas.microsoft.com/office/drawing/2014/main" id="{6D586F69-F4D7-4ABE-A1D3-E507B78D3B65}"/>
+                <a16:creationId xmlns:a16="http://schemas.microsoft.com/office/drawing/2014/main" id="{EA036648-5ED0-4834-94AB-BC73AD5D84C5}"/>
               </a:ext>
             </a:extLst>
           </p:cNvPr>
@@ -7485,7 +7543,7 @@
           <p:cNvPr id="4" name="">
             <a:extLst xmlns:a="http://schemas.openxmlformats.org/drawingml/2006/main">
               <a:ext uri="{FF2B5EF4-FFF2-40B4-BE49-F238E27FC236}">
-                <a16:creationId xmlns:a16="http://schemas.microsoft.com/office/drawing/2014/main" id="{4B17E225-16D8-4F4E-8C63-4ED6D08AEA0C}"/>
+                <a16:creationId xmlns:a16="http://schemas.microsoft.com/office/drawing/2014/main" id="{DB8DF998-6E45-4D84-89B6-2FC93C91ED46}"/>
               </a:ext>
             </a:extLst>
           </p:cNvPr>
@@ -7518,7 +7576,7 @@
           <p:cNvPr id="5" name="">
             <a:extLst xmlns:a="http://schemas.openxmlformats.org/drawingml/2006/main">
               <a:ext uri="{FF2B5EF4-FFF2-40B4-BE49-F238E27FC236}">
-                <a16:creationId xmlns:a16="http://schemas.microsoft.com/office/drawing/2014/main" id="{890B9099-537B-4BF9-BE9E-13CD6605E04E}"/>
+                <a16:creationId xmlns:a16="http://schemas.microsoft.com/office/drawing/2014/main" id="{10EC554E-293E-429A-8E27-45FAB4E4794F}"/>
               </a:ext>
             </a:extLst>
           </p:cNvPr>
@@ -7553,7 +7611,7 @@
           <p:cNvPr id="6" name="">
             <a:extLst xmlns:a="http://schemas.openxmlformats.org/drawingml/2006/main">
               <a:ext uri="{FF2B5EF4-FFF2-40B4-BE49-F238E27FC236}">
-                <a16:creationId xmlns:a16="http://schemas.microsoft.com/office/drawing/2014/main" id="{9CD46ADB-8E49-4A85-AF4A-84C053C67902}"/>
+                <a16:creationId xmlns:a16="http://schemas.microsoft.com/office/drawing/2014/main" id="{EF1F38FF-5A81-45A7-A7DD-16F91AB61502}"/>
               </a:ext>
             </a:extLst>
           </p:cNvPr>
@@ -7586,7 +7644,7 @@
           <p:cNvPr id="7" name="">
             <a:extLst xmlns:a="http://schemas.openxmlformats.org/drawingml/2006/main">
               <a:ext uri="{FF2B5EF4-FFF2-40B4-BE49-F238E27FC236}">
-                <a16:creationId xmlns:a16="http://schemas.microsoft.com/office/drawing/2014/main" id="{73931126-8CE7-4899-AA25-8F0BE68D851A}"/>
+                <a16:creationId xmlns:a16="http://schemas.microsoft.com/office/drawing/2014/main" id="{77A38F77-FBEC-4EA3-9DB1-794EF20E6C63}"/>
               </a:ext>
             </a:extLst>
           </p:cNvPr>
@@ -7644,7 +7702,7 @@
           <p:cNvPr id="8" name="">
             <a:extLst xmlns:a="http://schemas.openxmlformats.org/drawingml/2006/main">
               <a:ext uri="{FF2B5EF4-FFF2-40B4-BE49-F238E27FC236}">
-                <a16:creationId xmlns:a16="http://schemas.microsoft.com/office/drawing/2014/main" id="{585EBC51-FC25-4C09-85F6-B80EB92255B9}"/>
+                <a16:creationId xmlns:a16="http://schemas.microsoft.com/office/drawing/2014/main" id="{A1265128-D521-4E97-A5A8-D9B51582136A}"/>
               </a:ext>
             </a:extLst>
           </p:cNvPr>
@@ -7776,7 +7834,7 @@
           <p:cNvPr id="9" name="">
             <a:extLst xmlns:a="http://schemas.openxmlformats.org/drawingml/2006/main">
               <a:ext uri="{FF2B5EF4-FFF2-40B4-BE49-F238E27FC236}">
-                <a16:creationId xmlns:a16="http://schemas.microsoft.com/office/drawing/2014/main" id="{737A0CE1-1128-4038-A737-72CFDB0BA0B0}"/>
+                <a16:creationId xmlns:a16="http://schemas.microsoft.com/office/drawing/2014/main" id="{D0BB75D7-8081-4A0D-B84D-C9D221E77FF4}"/>
               </a:ext>
             </a:extLst>
           </p:cNvPr>
@@ -7811,7 +7869,7 @@
           <p:cNvPr id="10" name="">
             <a:extLst xmlns:a="http://schemas.openxmlformats.org/drawingml/2006/main">
               <a:ext uri="{FF2B5EF4-FFF2-40B4-BE49-F238E27FC236}">
-                <a16:creationId xmlns:a16="http://schemas.microsoft.com/office/drawing/2014/main" id="{43472057-A846-4926-B8D1-E0535F426C95}"/>
+                <a16:creationId xmlns:a16="http://schemas.microsoft.com/office/drawing/2014/main" id="{66298252-C9C7-4640-BD02-134E4FFDED4C}"/>
               </a:ext>
             </a:extLst>
           </p:cNvPr>
@@ -7844,7 +7902,7 @@
           <p:cNvPr id="11" name="">
             <a:extLst xmlns:a="http://schemas.openxmlformats.org/drawingml/2006/main">
               <a:ext uri="{FF2B5EF4-FFF2-40B4-BE49-F238E27FC236}">
-                <a16:creationId xmlns:a16="http://schemas.microsoft.com/office/drawing/2014/main" id="{32DFA451-6047-4D61-8A1D-D64789C383B4}"/>
+                <a16:creationId xmlns:a16="http://schemas.microsoft.com/office/drawing/2014/main" id="{2EB7C326-6C4D-4BC0-BBA9-FB6F9FEA170F}"/>
               </a:ext>
             </a:extLst>
           </p:cNvPr>
@@ -7902,7 +7960,7 @@
           <p:cNvPr id="12" name="">
             <a:extLst xmlns:a="http://schemas.openxmlformats.org/drawingml/2006/main">
               <a:ext uri="{FF2B5EF4-FFF2-40B4-BE49-F238E27FC236}">
-                <a16:creationId xmlns:a16="http://schemas.microsoft.com/office/drawing/2014/main" id="{CD218F6A-88F9-4C73-B526-231D08189629}"/>
+                <a16:creationId xmlns:a16="http://schemas.microsoft.com/office/drawing/2014/main" id="{CCF9AFDD-33DB-4F49-BBB0-35B52C053470}"/>
               </a:ext>
             </a:extLst>
           </p:cNvPr>
@@ -8034,7 +8092,7 @@
           <p:cNvPr id="13" name="">
             <a:extLst xmlns:a="http://schemas.openxmlformats.org/drawingml/2006/main">
               <a:ext uri="{FF2B5EF4-FFF2-40B4-BE49-F238E27FC236}">
-                <a16:creationId xmlns:a16="http://schemas.microsoft.com/office/drawing/2014/main" id="{1AA38D03-56CE-4663-A254-1640467D2FAA}"/>
+                <a16:creationId xmlns:a16="http://schemas.microsoft.com/office/drawing/2014/main" id="{78498B06-2F49-4001-B8BF-BCEB1799188F}"/>
               </a:ext>
             </a:extLst>
           </p:cNvPr>
@@ -8069,7 +8127,7 @@
           <p:cNvPr id="14" name="">
             <a:extLst xmlns:a="http://schemas.openxmlformats.org/drawingml/2006/main">
               <a:ext uri="{FF2B5EF4-FFF2-40B4-BE49-F238E27FC236}">
-                <a16:creationId xmlns:a16="http://schemas.microsoft.com/office/drawing/2014/main" id="{09A3B702-BCA3-454B-B570-CB2DE0E0011B}"/>
+                <a16:creationId xmlns:a16="http://schemas.microsoft.com/office/drawing/2014/main" id="{759BB647-8A89-4C52-A0FE-AFC93A4A5606}"/>
               </a:ext>
             </a:extLst>
           </p:cNvPr>
@@ -8102,7 +8160,7 @@
           <p:cNvPr id="15" name="">
             <a:extLst xmlns:a="http://schemas.openxmlformats.org/drawingml/2006/main">
               <a:ext uri="{FF2B5EF4-FFF2-40B4-BE49-F238E27FC236}">
-                <a16:creationId xmlns:a16="http://schemas.microsoft.com/office/drawing/2014/main" id="{A77C6F2B-3570-4487-836B-0AC37AFC054B}"/>
+                <a16:creationId xmlns:a16="http://schemas.microsoft.com/office/drawing/2014/main" id="{8E5C7495-E4E6-4FE1-B646-F4531723626C}"/>
               </a:ext>
             </a:extLst>
           </p:cNvPr>
@@ -8160,7 +8218,7 @@
           <p:cNvPr id="16" name="">
             <a:extLst xmlns:a="http://schemas.openxmlformats.org/drawingml/2006/main">
               <a:ext uri="{FF2B5EF4-FFF2-40B4-BE49-F238E27FC236}">
-                <a16:creationId xmlns:a16="http://schemas.microsoft.com/office/drawing/2014/main" id="{401BDF15-56E6-4E0C-908C-8D130070EB41}"/>
+                <a16:creationId xmlns:a16="http://schemas.microsoft.com/office/drawing/2014/main" id="{94BB3BB5-B6B6-4949-8F8D-C95DEA102567}"/>
               </a:ext>
             </a:extLst>
           </p:cNvPr>
@@ -8292,7 +8350,7 @@
           <p:cNvPr id="17" name="">
             <a:extLst xmlns:a="http://schemas.openxmlformats.org/drawingml/2006/main">
               <a:ext uri="{FF2B5EF4-FFF2-40B4-BE49-F238E27FC236}">
-                <a16:creationId xmlns:a16="http://schemas.microsoft.com/office/drawing/2014/main" id="{F6DD4E8D-644F-4CEF-9851-57BEACF6A1FF}"/>
+                <a16:creationId xmlns:a16="http://schemas.microsoft.com/office/drawing/2014/main" id="{B1196A3E-39B1-4BCB-892A-98FBB49022B9}"/>
               </a:ext>
             </a:extLst>
           </p:cNvPr>
@@ -8348,7 +8406,7 @@
     </p:spTree>
     <p:extLst>
       <p:ext uri="{BB962C8B-B14F-4D97-AF65-F5344CB8AC3E}">
-        <p14:creationId xmlns:p14="http://schemas.microsoft.com/office/powerpoint/2010/main" val="4672730"/>
+        <p14:creationId xmlns:p14="http://schemas.microsoft.com/office/powerpoint/2010/main" val="1512258914"/>
       </p:ext>
     </p:extLst>
   </p:cSld>
@@ -8379,7 +8437,7 @@
           <p:cNvPr id="41" name="">
             <a:extLst xmlns:a="http://schemas.openxmlformats.org/drawingml/2006/main">
               <a:ext uri="{FF2B5EF4-FFF2-40B4-BE49-F238E27FC236}">
-                <a16:creationId xmlns:a16="http://schemas.microsoft.com/office/drawing/2014/main" id="{43EAC9B2-3732-48D4-99FE-16A64794E095}"/>
+                <a16:creationId xmlns:a16="http://schemas.microsoft.com/office/drawing/2014/main" id="{52F03FE7-261E-4323-B6FE-23E0BBCD53B5}"/>
               </a:ext>
             </a:extLst>
           </p:cNvPr>
@@ -8437,7 +8495,7 @@
           <p:cNvPr id="2" name="">
             <a:extLst xmlns:a="http://schemas.openxmlformats.org/drawingml/2006/main">
               <a:ext uri="{FF2B5EF4-FFF2-40B4-BE49-F238E27FC236}">
-                <a16:creationId xmlns:a16="http://schemas.microsoft.com/office/drawing/2014/main" id="{059128AA-D584-42D9-AB86-8A8C8362F1BB}"/>
+                <a16:creationId xmlns:a16="http://schemas.microsoft.com/office/drawing/2014/main" id="{7C8138F8-831F-42E4-9946-39FD227D7344}"/>
               </a:ext>
             </a:extLst>
           </p:cNvPr>
@@ -8495,7 +8553,7 @@
           <p:cNvPr id="3" name="">
             <a:extLst xmlns:a="http://schemas.openxmlformats.org/drawingml/2006/main">
               <a:ext uri="{FF2B5EF4-FFF2-40B4-BE49-F238E27FC236}">
-                <a16:creationId xmlns:a16="http://schemas.microsoft.com/office/drawing/2014/main" id="{AA06A3C5-2F95-4FD2-944E-5FD5F0270C49}"/>
+                <a16:creationId xmlns:a16="http://schemas.microsoft.com/office/drawing/2014/main" id="{EFA939B6-2FD5-45EF-A390-2EF9EDA353C4}"/>
               </a:ext>
             </a:extLst>
           </p:cNvPr>
@@ -8553,7 +8611,7 @@
           <p:cNvPr id="4" name="">
             <a:extLst xmlns:a="http://schemas.openxmlformats.org/drawingml/2006/main">
               <a:ext uri="{FF2B5EF4-FFF2-40B4-BE49-F238E27FC236}">
-                <a16:creationId xmlns:a16="http://schemas.microsoft.com/office/drawing/2014/main" id="{506578B9-8D7C-4E5D-B7B9-B49153DF33B4}"/>
+                <a16:creationId xmlns:a16="http://schemas.microsoft.com/office/drawing/2014/main" id="{76969831-CFE3-47DF-868E-4DB7873AA1B1}"/>
               </a:ext>
             </a:extLst>
           </p:cNvPr>
@@ -8586,7 +8644,7 @@
           <p:cNvPr id="5" name="">
             <a:extLst xmlns:a="http://schemas.openxmlformats.org/drawingml/2006/main">
               <a:ext uri="{FF2B5EF4-FFF2-40B4-BE49-F238E27FC236}">
-                <a16:creationId xmlns:a16="http://schemas.microsoft.com/office/drawing/2014/main" id="{783CC493-7F5D-4729-8AF3-699A61C8A9FC}"/>
+                <a16:creationId xmlns:a16="http://schemas.microsoft.com/office/drawing/2014/main" id="{02825BC6-015C-4434-8FE6-5C91AAF5ED33}"/>
               </a:ext>
             </a:extLst>
           </p:cNvPr>
@@ -8621,7 +8679,7 @@
           <p:cNvPr id="6" name="">
             <a:extLst xmlns:a="http://schemas.openxmlformats.org/drawingml/2006/main">
               <a:ext uri="{FF2B5EF4-FFF2-40B4-BE49-F238E27FC236}">
-                <a16:creationId xmlns:a16="http://schemas.microsoft.com/office/drawing/2014/main" id="{6347FBD5-1FE7-4A33-829D-2BD63479B061}"/>
+                <a16:creationId xmlns:a16="http://schemas.microsoft.com/office/drawing/2014/main" id="{93643E9E-C545-49B1-B6F6-A7B2FD5662A3}"/>
               </a:ext>
             </a:extLst>
           </p:cNvPr>
@@ -8654,7 +8712,7 @@
           <p:cNvPr id="7" name="">
             <a:extLst xmlns:a="http://schemas.openxmlformats.org/drawingml/2006/main">
               <a:ext uri="{FF2B5EF4-FFF2-40B4-BE49-F238E27FC236}">
-                <a16:creationId xmlns:a16="http://schemas.microsoft.com/office/drawing/2014/main" id="{67C2F9E3-8EFD-43F1-B312-1C1D0749AB23}"/>
+                <a16:creationId xmlns:a16="http://schemas.microsoft.com/office/drawing/2014/main" id="{F94CA5AC-9C7E-4B59-8463-7F4F4062EF20}"/>
               </a:ext>
             </a:extLst>
           </p:cNvPr>
@@ -8712,7 +8770,7 @@
           <p:cNvPr id="8" name="">
             <a:extLst xmlns:a="http://schemas.openxmlformats.org/drawingml/2006/main">
               <a:ext uri="{FF2B5EF4-FFF2-40B4-BE49-F238E27FC236}">
-                <a16:creationId xmlns:a16="http://schemas.microsoft.com/office/drawing/2014/main" id="{9B7ECDD7-1936-4A32-A035-B701DEAE12D9}"/>
+                <a16:creationId xmlns:a16="http://schemas.microsoft.com/office/drawing/2014/main" id="{BB053806-500B-4FB5-91DB-F0C13077BE41}"/>
               </a:ext>
             </a:extLst>
           </p:cNvPr>
@@ -8770,7 +8828,7 @@
           <p:cNvPr id="9" name="">
             <a:extLst xmlns:a="http://schemas.openxmlformats.org/drawingml/2006/main">
               <a:ext uri="{FF2B5EF4-FFF2-40B4-BE49-F238E27FC236}">
-                <a16:creationId xmlns:a16="http://schemas.microsoft.com/office/drawing/2014/main" id="{3598C006-7AC5-4C35-BB16-7A0B0BE35488}"/>
+                <a16:creationId xmlns:a16="http://schemas.microsoft.com/office/drawing/2014/main" id="{FA4D0C43-C065-4190-AD63-BB5E7E0B366D}"/>
               </a:ext>
             </a:extLst>
           </p:cNvPr>
@@ -8874,7 +8932,7 @@
           <p:cNvPr id="10" name="">
             <a:extLst xmlns:a="http://schemas.openxmlformats.org/drawingml/2006/main">
               <a:ext uri="{FF2B5EF4-FFF2-40B4-BE49-F238E27FC236}">
-                <a16:creationId xmlns:a16="http://schemas.microsoft.com/office/drawing/2014/main" id="{81F5ECC8-18B4-42B1-A961-445AED7981C3}"/>
+                <a16:creationId xmlns:a16="http://schemas.microsoft.com/office/drawing/2014/main" id="{1EEEB57B-D59C-456F-B78E-AF44D5C0EADE}"/>
               </a:ext>
             </a:extLst>
           </p:cNvPr>
@@ -8907,7 +8965,7 @@
           <p:cNvPr id="11" name="">
             <a:extLst xmlns:a="http://schemas.openxmlformats.org/drawingml/2006/main">
               <a:ext uri="{FF2B5EF4-FFF2-40B4-BE49-F238E27FC236}">
-                <a16:creationId xmlns:a16="http://schemas.microsoft.com/office/drawing/2014/main" id="{340ED5B2-4DFA-45EC-BE72-F94A617DDCF2}"/>
+                <a16:creationId xmlns:a16="http://schemas.microsoft.com/office/drawing/2014/main" id="{40D259F4-6A47-43BD-BF10-9172B1A0A48A}"/>
               </a:ext>
             </a:extLst>
           </p:cNvPr>
@@ -8942,7 +9000,7 @@
           <p:cNvPr id="12" name="">
             <a:extLst xmlns:a="http://schemas.openxmlformats.org/drawingml/2006/main">
               <a:ext uri="{FF2B5EF4-FFF2-40B4-BE49-F238E27FC236}">
-                <a16:creationId xmlns:a16="http://schemas.microsoft.com/office/drawing/2014/main" id="{87C391D8-3F0A-4709-913F-0729E500B8B8}"/>
+                <a16:creationId xmlns:a16="http://schemas.microsoft.com/office/drawing/2014/main" id="{0870F338-3404-48C8-A07A-AB009FCAAFDD}"/>
               </a:ext>
             </a:extLst>
           </p:cNvPr>
@@ -8975,7 +9033,7 @@
           <p:cNvPr id="13" name="">
             <a:extLst xmlns:a="http://schemas.openxmlformats.org/drawingml/2006/main">
               <a:ext uri="{FF2B5EF4-FFF2-40B4-BE49-F238E27FC236}">
-                <a16:creationId xmlns:a16="http://schemas.microsoft.com/office/drawing/2014/main" id="{32D912A4-3EA7-444D-BE4D-93590F02CFC9}"/>
+                <a16:creationId xmlns:a16="http://schemas.microsoft.com/office/drawing/2014/main" id="{D920E5AD-D45F-40B4-9294-F1FAD0475D83}"/>
               </a:ext>
             </a:extLst>
           </p:cNvPr>
@@ -9033,7 +9091,7 @@
           <p:cNvPr id="14" name="">
             <a:extLst xmlns:a="http://schemas.openxmlformats.org/drawingml/2006/main">
               <a:ext uri="{FF2B5EF4-FFF2-40B4-BE49-F238E27FC236}">
-                <a16:creationId xmlns:a16="http://schemas.microsoft.com/office/drawing/2014/main" id="{9B15519A-866D-4205-ABCA-EE651D2E7A63}"/>
+                <a16:creationId xmlns:a16="http://schemas.microsoft.com/office/drawing/2014/main" id="{1B837833-181B-44D1-9B6A-FAE5774B2F6D}"/>
               </a:ext>
             </a:extLst>
           </p:cNvPr>
@@ -9091,7 +9149,7 @@
           <p:cNvPr id="15" name="">
             <a:extLst xmlns:a="http://schemas.openxmlformats.org/drawingml/2006/main">
               <a:ext uri="{FF2B5EF4-FFF2-40B4-BE49-F238E27FC236}">
-                <a16:creationId xmlns:a16="http://schemas.microsoft.com/office/drawing/2014/main" id="{DC6CD4ED-A814-45AC-873B-05501C9E4862}"/>
+                <a16:creationId xmlns:a16="http://schemas.microsoft.com/office/drawing/2014/main" id="{4AEDCE15-0427-49FA-9F5C-29BBC5EA9C3D}"/>
               </a:ext>
             </a:extLst>
           </p:cNvPr>
@@ -9195,7 +9253,7 @@
           <p:cNvPr id="16" name="">
             <a:extLst xmlns:a="http://schemas.openxmlformats.org/drawingml/2006/main">
               <a:ext uri="{FF2B5EF4-FFF2-40B4-BE49-F238E27FC236}">
-                <a16:creationId xmlns:a16="http://schemas.microsoft.com/office/drawing/2014/main" id="{CD762E8B-4A58-4CA2-AFE8-9B2821BD600C}"/>
+                <a16:creationId xmlns:a16="http://schemas.microsoft.com/office/drawing/2014/main" id="{6BB58EC7-40EE-4F84-B1AD-1E08D51B63F0}"/>
               </a:ext>
             </a:extLst>
           </p:cNvPr>
@@ -9228,7 +9286,7 @@
           <p:cNvPr id="17" name="">
             <a:extLst xmlns:a="http://schemas.openxmlformats.org/drawingml/2006/main">
               <a:ext uri="{FF2B5EF4-FFF2-40B4-BE49-F238E27FC236}">
-                <a16:creationId xmlns:a16="http://schemas.microsoft.com/office/drawing/2014/main" id="{AD8BF9B3-B5B1-4C81-BBE9-9C51C088A473}"/>
+                <a16:creationId xmlns:a16="http://schemas.microsoft.com/office/drawing/2014/main" id="{A10D6459-B6E8-4701-8FAA-852B063F8FC2}"/>
               </a:ext>
             </a:extLst>
           </p:cNvPr>
@@ -9263,7 +9321,7 @@
           <p:cNvPr id="18" name="">
             <a:extLst xmlns:a="http://schemas.openxmlformats.org/drawingml/2006/main">
               <a:ext uri="{FF2B5EF4-FFF2-40B4-BE49-F238E27FC236}">
-                <a16:creationId xmlns:a16="http://schemas.microsoft.com/office/drawing/2014/main" id="{FD1DBFEE-9A65-4844-A9BE-BF01A37DB612}"/>
+                <a16:creationId xmlns:a16="http://schemas.microsoft.com/office/drawing/2014/main" id="{C04F83A5-622C-4FD3-BA2C-B56BBC9395DA}"/>
               </a:ext>
             </a:extLst>
           </p:cNvPr>
@@ -9296,7 +9354,7 @@
           <p:cNvPr id="19" name="">
             <a:extLst xmlns:a="http://schemas.openxmlformats.org/drawingml/2006/main">
               <a:ext uri="{FF2B5EF4-FFF2-40B4-BE49-F238E27FC236}">
-                <a16:creationId xmlns:a16="http://schemas.microsoft.com/office/drawing/2014/main" id="{3C7AD217-598A-4000-AE27-7A38F96247AB}"/>
+                <a16:creationId xmlns:a16="http://schemas.microsoft.com/office/drawing/2014/main" id="{7178CE96-7EB7-49B4-BFFE-C8A7ABBEFD04}"/>
               </a:ext>
             </a:extLst>
           </p:cNvPr>
@@ -9354,7 +9412,7 @@
           <p:cNvPr id="20" name="">
             <a:extLst xmlns:a="http://schemas.openxmlformats.org/drawingml/2006/main">
               <a:ext uri="{FF2B5EF4-FFF2-40B4-BE49-F238E27FC236}">
-                <a16:creationId xmlns:a16="http://schemas.microsoft.com/office/drawing/2014/main" id="{D74EC1EF-35E6-4A66-BAA5-C506C282C6B8}"/>
+                <a16:creationId xmlns:a16="http://schemas.microsoft.com/office/drawing/2014/main" id="{5CC40FCF-0294-433E-AD12-E17EBA7C1F96}"/>
               </a:ext>
             </a:extLst>
           </p:cNvPr>
@@ -9412,7 +9470,7 @@
           <p:cNvPr id="21" name="">
             <a:extLst xmlns:a="http://schemas.openxmlformats.org/drawingml/2006/main">
               <a:ext uri="{FF2B5EF4-FFF2-40B4-BE49-F238E27FC236}">
-                <a16:creationId xmlns:a16="http://schemas.microsoft.com/office/drawing/2014/main" id="{464D78F5-DA41-43C8-8336-7F8FB663E9D0}"/>
+                <a16:creationId xmlns:a16="http://schemas.microsoft.com/office/drawing/2014/main" id="{BE490D7C-444C-4043-95C6-4FE5C327076F}"/>
               </a:ext>
             </a:extLst>
           </p:cNvPr>
@@ -9516,7 +9574,7 @@
           <p:cNvPr id="22" name="">
             <a:extLst xmlns:a="http://schemas.openxmlformats.org/drawingml/2006/main">
               <a:ext uri="{FF2B5EF4-FFF2-40B4-BE49-F238E27FC236}">
-                <a16:creationId xmlns:a16="http://schemas.microsoft.com/office/drawing/2014/main" id="{64971438-F376-45FA-803A-BAE23A5B3E3B}"/>
+                <a16:creationId xmlns:a16="http://schemas.microsoft.com/office/drawing/2014/main" id="{8B78B52A-88D5-451D-83C9-8106E7D3DB90}"/>
               </a:ext>
             </a:extLst>
           </p:cNvPr>
@@ -9549,7 +9607,7 @@
           <p:cNvPr id="23" name="">
             <a:extLst xmlns:a="http://schemas.openxmlformats.org/drawingml/2006/main">
               <a:ext uri="{FF2B5EF4-FFF2-40B4-BE49-F238E27FC236}">
-                <a16:creationId xmlns:a16="http://schemas.microsoft.com/office/drawing/2014/main" id="{9454115A-80C3-4296-99BF-CB48572200DF}"/>
+                <a16:creationId xmlns:a16="http://schemas.microsoft.com/office/drawing/2014/main" id="{8CF86CA8-F3F5-4C26-8A72-E2D0992E7468}"/>
               </a:ext>
             </a:extLst>
           </p:cNvPr>
@@ -9584,7 +9642,7 @@
           <p:cNvPr id="24" name="">
             <a:extLst xmlns:a="http://schemas.openxmlformats.org/drawingml/2006/main">
               <a:ext uri="{FF2B5EF4-FFF2-40B4-BE49-F238E27FC236}">
-                <a16:creationId xmlns:a16="http://schemas.microsoft.com/office/drawing/2014/main" id="{BB07C5AA-041A-4E5F-86E4-99608F240010}"/>
+                <a16:creationId xmlns:a16="http://schemas.microsoft.com/office/drawing/2014/main" id="{12E3939A-77C7-44DC-BA3C-767D725BEB59}"/>
               </a:ext>
             </a:extLst>
           </p:cNvPr>
@@ -9617,7 +9675,7 @@
           <p:cNvPr id="25" name="">
             <a:extLst xmlns:a="http://schemas.openxmlformats.org/drawingml/2006/main">
               <a:ext uri="{FF2B5EF4-FFF2-40B4-BE49-F238E27FC236}">
-                <a16:creationId xmlns:a16="http://schemas.microsoft.com/office/drawing/2014/main" id="{B720F1AE-33E1-4EF0-9CFF-6E4C0F8338DE}"/>
+                <a16:creationId xmlns:a16="http://schemas.microsoft.com/office/drawing/2014/main" id="{ABDD9A81-7CFC-4B85-BF92-B4A18D0CC693}"/>
               </a:ext>
             </a:extLst>
           </p:cNvPr>
@@ -9675,7 +9733,7 @@
           <p:cNvPr id="26" name="">
             <a:extLst xmlns:a="http://schemas.openxmlformats.org/drawingml/2006/main">
               <a:ext uri="{FF2B5EF4-FFF2-40B4-BE49-F238E27FC236}">
-                <a16:creationId xmlns:a16="http://schemas.microsoft.com/office/drawing/2014/main" id="{00D7C5C4-90E6-475E-A918-C535BFBA4192}"/>
+                <a16:creationId xmlns:a16="http://schemas.microsoft.com/office/drawing/2014/main" id="{BA0303C3-C8DD-4DBB-A21A-A6B8FA26CC1D}"/>
               </a:ext>
             </a:extLst>
           </p:cNvPr>
@@ -9733,7 +9791,7 @@
           <p:cNvPr id="27" name="">
             <a:extLst xmlns:a="http://schemas.openxmlformats.org/drawingml/2006/main">
               <a:ext uri="{FF2B5EF4-FFF2-40B4-BE49-F238E27FC236}">
-                <a16:creationId xmlns:a16="http://schemas.microsoft.com/office/drawing/2014/main" id="{5A8DCFE0-74B8-4404-87B8-2199156C7889}"/>
+                <a16:creationId xmlns:a16="http://schemas.microsoft.com/office/drawing/2014/main" id="{F39D7C06-C3E4-4636-8512-90A8DE1B791B}"/>
               </a:ext>
             </a:extLst>
           </p:cNvPr>
@@ -9837,7 +9895,7 @@
           <p:cNvPr id="28" name="">
             <a:extLst xmlns:a="http://schemas.openxmlformats.org/drawingml/2006/main">
               <a:ext uri="{FF2B5EF4-FFF2-40B4-BE49-F238E27FC236}">
-                <a16:creationId xmlns:a16="http://schemas.microsoft.com/office/drawing/2014/main" id="{ABB7ACFC-B631-4E8B-9A65-4EB538B0D36A}"/>
+                <a16:creationId xmlns:a16="http://schemas.microsoft.com/office/drawing/2014/main" id="{590D863F-7102-466A-AC0E-4288D7749111}"/>
               </a:ext>
             </a:extLst>
           </p:cNvPr>
@@ -9870,7 +9928,7 @@
           <p:cNvPr id="29" name="">
             <a:extLst xmlns:a="http://schemas.openxmlformats.org/drawingml/2006/main">
               <a:ext uri="{FF2B5EF4-FFF2-40B4-BE49-F238E27FC236}">
-                <a16:creationId xmlns:a16="http://schemas.microsoft.com/office/drawing/2014/main" id="{27AC105F-31D2-4A00-BDDF-3FFC5D248312}"/>
+                <a16:creationId xmlns:a16="http://schemas.microsoft.com/office/drawing/2014/main" id="{F9881818-C41B-4E01-87EB-625C77A0E735}"/>
               </a:ext>
             </a:extLst>
           </p:cNvPr>
@@ -9905,7 +9963,7 @@
           <p:cNvPr id="30" name="">
             <a:extLst xmlns:a="http://schemas.openxmlformats.org/drawingml/2006/main">
               <a:ext uri="{FF2B5EF4-FFF2-40B4-BE49-F238E27FC236}">
-                <a16:creationId xmlns:a16="http://schemas.microsoft.com/office/drawing/2014/main" id="{C185A17E-954D-4FE6-B582-F9D8F69AF9CC}"/>
+                <a16:creationId xmlns:a16="http://schemas.microsoft.com/office/drawing/2014/main" id="{FFEA2F49-0C5B-4F1E-9666-4655FFBB44A9}"/>
               </a:ext>
             </a:extLst>
           </p:cNvPr>
@@ -9938,7 +9996,7 @@
           <p:cNvPr id="31" name="">
             <a:extLst xmlns:a="http://schemas.openxmlformats.org/drawingml/2006/main">
               <a:ext uri="{FF2B5EF4-FFF2-40B4-BE49-F238E27FC236}">
-                <a16:creationId xmlns:a16="http://schemas.microsoft.com/office/drawing/2014/main" id="{9BBA0425-AC19-4593-A898-32161FCB6080}"/>
+                <a16:creationId xmlns:a16="http://schemas.microsoft.com/office/drawing/2014/main" id="{706EBFF2-AA54-4925-90AF-744D12D1FFB4}"/>
               </a:ext>
             </a:extLst>
           </p:cNvPr>
@@ -9996,7 +10054,7 @@
           <p:cNvPr id="32" name="">
             <a:extLst xmlns:a="http://schemas.openxmlformats.org/drawingml/2006/main">
               <a:ext uri="{FF2B5EF4-FFF2-40B4-BE49-F238E27FC236}">
-                <a16:creationId xmlns:a16="http://schemas.microsoft.com/office/drawing/2014/main" id="{86FED958-2B92-4BB0-8A1E-A2C28778C621}"/>
+                <a16:creationId xmlns:a16="http://schemas.microsoft.com/office/drawing/2014/main" id="{5EFAA765-C434-4964-838E-04119D00DE52}"/>
               </a:ext>
             </a:extLst>
           </p:cNvPr>
@@ -10054,7 +10112,7 @@
           <p:cNvPr id="33" name="">
             <a:extLst xmlns:a="http://schemas.openxmlformats.org/drawingml/2006/main">
               <a:ext uri="{FF2B5EF4-FFF2-40B4-BE49-F238E27FC236}">
-                <a16:creationId xmlns:a16="http://schemas.microsoft.com/office/drawing/2014/main" id="{ADF7A79E-CE71-44DA-B865-447E4ECC3991}"/>
+                <a16:creationId xmlns:a16="http://schemas.microsoft.com/office/drawing/2014/main" id="{A034A9D5-2E17-4879-9567-F9956B1234C4}"/>
               </a:ext>
             </a:extLst>
           </p:cNvPr>
@@ -10158,7 +10216,7 @@
           <p:cNvPr id="34" name="">
             <a:extLst xmlns:a="http://schemas.openxmlformats.org/drawingml/2006/main">
               <a:ext uri="{FF2B5EF4-FFF2-40B4-BE49-F238E27FC236}">
-                <a16:creationId xmlns:a16="http://schemas.microsoft.com/office/drawing/2014/main" id="{7A38EAE7-FC72-4ACF-915D-CDA93B1618B8}"/>
+                <a16:creationId xmlns:a16="http://schemas.microsoft.com/office/drawing/2014/main" id="{34FA1CD2-AB9E-4F69-9227-76EDC7C287F7}"/>
               </a:ext>
             </a:extLst>
           </p:cNvPr>
@@ -10191,7 +10249,7 @@
           <p:cNvPr id="35" name="">
             <a:extLst xmlns:a="http://schemas.openxmlformats.org/drawingml/2006/main">
               <a:ext uri="{FF2B5EF4-FFF2-40B4-BE49-F238E27FC236}">
-                <a16:creationId xmlns:a16="http://schemas.microsoft.com/office/drawing/2014/main" id="{F34BFC8E-F145-409C-B338-E8F4F3EAF500}"/>
+                <a16:creationId xmlns:a16="http://schemas.microsoft.com/office/drawing/2014/main" id="{D25C297E-410C-4D2D-B2D1-EF57D953A42F}"/>
               </a:ext>
             </a:extLst>
           </p:cNvPr>
@@ -10226,7 +10284,7 @@
           <p:cNvPr id="36" name="">
             <a:extLst xmlns:a="http://schemas.openxmlformats.org/drawingml/2006/main">
               <a:ext uri="{FF2B5EF4-FFF2-40B4-BE49-F238E27FC236}">
-                <a16:creationId xmlns:a16="http://schemas.microsoft.com/office/drawing/2014/main" id="{7251D221-3D26-4A96-97E5-1A0067836A35}"/>
+                <a16:creationId xmlns:a16="http://schemas.microsoft.com/office/drawing/2014/main" id="{29D8DBA4-C3A4-4A69-BF3C-8DFCBFEB6A46}"/>
               </a:ext>
             </a:extLst>
           </p:cNvPr>
@@ -10259,7 +10317,7 @@
           <p:cNvPr id="37" name="">
             <a:extLst xmlns:a="http://schemas.openxmlformats.org/drawingml/2006/main">
               <a:ext uri="{FF2B5EF4-FFF2-40B4-BE49-F238E27FC236}">
-                <a16:creationId xmlns:a16="http://schemas.microsoft.com/office/drawing/2014/main" id="{33D77EEC-9315-4DB5-A449-633D035738D5}"/>
+                <a16:creationId xmlns:a16="http://schemas.microsoft.com/office/drawing/2014/main" id="{8F19DE2C-DC04-4E46-8FD6-A58C6AE359B9}"/>
               </a:ext>
             </a:extLst>
           </p:cNvPr>
@@ -10317,7 +10375,7 @@
           <p:cNvPr id="38" name="">
             <a:extLst xmlns:a="http://schemas.openxmlformats.org/drawingml/2006/main">
               <a:ext uri="{FF2B5EF4-FFF2-40B4-BE49-F238E27FC236}">
-                <a16:creationId xmlns:a16="http://schemas.microsoft.com/office/drawing/2014/main" id="{7D729006-B653-46B2-8C1A-0E8B97DD2021}"/>
+                <a16:creationId xmlns:a16="http://schemas.microsoft.com/office/drawing/2014/main" id="{38100DA8-C04E-487F-A5E8-5715A914ADC0}"/>
               </a:ext>
             </a:extLst>
           </p:cNvPr>
@@ -10375,7 +10433,7 @@
           <p:cNvPr id="39" name="">
             <a:extLst xmlns:a="http://schemas.openxmlformats.org/drawingml/2006/main">
               <a:ext uri="{FF2B5EF4-FFF2-40B4-BE49-F238E27FC236}">
-                <a16:creationId xmlns:a16="http://schemas.microsoft.com/office/drawing/2014/main" id="{CED72133-58B3-491A-A79D-0313FF5AB9C1}"/>
+                <a16:creationId xmlns:a16="http://schemas.microsoft.com/office/drawing/2014/main" id="{769EE403-C329-4ADE-A667-BB0E902423BF}"/>
               </a:ext>
             </a:extLst>
           </p:cNvPr>
@@ -10479,7 +10537,7 @@
           <p:cNvPr id="40" name="">
             <a:extLst xmlns:a="http://schemas.openxmlformats.org/drawingml/2006/main">
               <a:ext uri="{FF2B5EF4-FFF2-40B4-BE49-F238E27FC236}">
-                <a16:creationId xmlns:a16="http://schemas.microsoft.com/office/drawing/2014/main" id="{EBF7CE64-713D-406A-8485-366FC451BE75}"/>
+                <a16:creationId xmlns:a16="http://schemas.microsoft.com/office/drawing/2014/main" id="{25449D5B-3C4E-4EC2-968A-EA65D4D1B6ED}"/>
               </a:ext>
             </a:extLst>
           </p:cNvPr>
@@ -10535,7 +10593,7 @@
     </p:spTree>
     <p:extLst>
       <p:ext uri="{BB962C8B-B14F-4D97-AF65-F5344CB8AC3E}">
-        <p14:creationId xmlns:p14="http://schemas.microsoft.com/office/powerpoint/2010/main" val="304302589"/>
+        <p14:creationId xmlns:p14="http://schemas.microsoft.com/office/powerpoint/2010/main" val="1119450007"/>
       </p:ext>
     </p:extLst>
   </p:cSld>
@@ -10566,7 +10624,7 @@
           <p:cNvPr id="18" name="">
             <a:extLst xmlns:a="http://schemas.openxmlformats.org/drawingml/2006/main">
               <a:ext uri="{FF2B5EF4-FFF2-40B4-BE49-F238E27FC236}">
-                <a16:creationId xmlns:a16="http://schemas.microsoft.com/office/drawing/2014/main" id="{2D25774C-6EEB-46E7-ABA0-05A4C2222662}"/>
+                <a16:creationId xmlns:a16="http://schemas.microsoft.com/office/drawing/2014/main" id="{ACFAD537-89F4-47EE-8ABD-C56121F6D7CC}"/>
               </a:ext>
             </a:extLst>
           </p:cNvPr>
@@ -10624,7 +10682,7 @@
           <p:cNvPr id="2" name="">
             <a:extLst xmlns:a="http://schemas.openxmlformats.org/drawingml/2006/main">
               <a:ext uri="{FF2B5EF4-FFF2-40B4-BE49-F238E27FC236}">
-                <a16:creationId xmlns:a16="http://schemas.microsoft.com/office/drawing/2014/main" id="{2381F0B3-4BC9-4C9E-A1F1-EDBF751A54F8}"/>
+                <a16:creationId xmlns:a16="http://schemas.microsoft.com/office/drawing/2014/main" id="{22C7D6AB-00EB-40D3-B6F2-0EEFE76384B5}"/>
               </a:ext>
             </a:extLst>
           </p:cNvPr>
@@ -10682,7 +10740,7 @@
           <p:cNvPr id="3" name="">
             <a:extLst xmlns:a="http://schemas.openxmlformats.org/drawingml/2006/main">
               <a:ext uri="{FF2B5EF4-FFF2-40B4-BE49-F238E27FC236}">
-                <a16:creationId xmlns:a16="http://schemas.microsoft.com/office/drawing/2014/main" id="{06452379-EA62-4364-82D3-2E64726EC959}"/>
+                <a16:creationId xmlns:a16="http://schemas.microsoft.com/office/drawing/2014/main" id="{94670344-4281-4C28-8EE7-8391DB3B48D5}"/>
               </a:ext>
             </a:extLst>
           </p:cNvPr>
@@ -10740,7 +10798,7 @@
           <p:cNvPr id="4" name="">
             <a:extLst xmlns:a="http://schemas.openxmlformats.org/drawingml/2006/main">
               <a:ext uri="{FF2B5EF4-FFF2-40B4-BE49-F238E27FC236}">
-                <a16:creationId xmlns:a16="http://schemas.microsoft.com/office/drawing/2014/main" id="{4FB051D8-EB4F-4C4B-B1A4-1A8DB9D74632}"/>
+                <a16:creationId xmlns:a16="http://schemas.microsoft.com/office/drawing/2014/main" id="{2BC97371-0700-4CB1-84B0-922A2F728EA8}"/>
               </a:ext>
             </a:extLst>
           </p:cNvPr>
@@ -10773,7 +10831,7 @@
           <p:cNvPr id="5" name="">
             <a:extLst xmlns:a="http://schemas.openxmlformats.org/drawingml/2006/main">
               <a:ext uri="{FF2B5EF4-FFF2-40B4-BE49-F238E27FC236}">
-                <a16:creationId xmlns:a16="http://schemas.microsoft.com/office/drawing/2014/main" id="{05492A8F-10AD-44F9-A3FB-BDDA2DB488FE}"/>
+                <a16:creationId xmlns:a16="http://schemas.microsoft.com/office/drawing/2014/main" id="{BDBF8083-A47F-49EA-A53A-9CC2F391B7FF}"/>
               </a:ext>
             </a:extLst>
           </p:cNvPr>
@@ -10808,7 +10866,7 @@
           <p:cNvPr id="6" name="">
             <a:extLst xmlns:a="http://schemas.openxmlformats.org/drawingml/2006/main">
               <a:ext uri="{FF2B5EF4-FFF2-40B4-BE49-F238E27FC236}">
-                <a16:creationId xmlns:a16="http://schemas.microsoft.com/office/drawing/2014/main" id="{C407DDF9-19C4-4914-9617-05280EF3DC1E}"/>
+                <a16:creationId xmlns:a16="http://schemas.microsoft.com/office/drawing/2014/main" id="{4555C8EE-C23D-4E4F-9FCF-B10E6358A98B}"/>
               </a:ext>
             </a:extLst>
           </p:cNvPr>
@@ -10841,7 +10899,7 @@
           <p:cNvPr id="7" name="">
             <a:extLst xmlns:a="http://schemas.openxmlformats.org/drawingml/2006/main">
               <a:ext uri="{FF2B5EF4-FFF2-40B4-BE49-F238E27FC236}">
-                <a16:creationId xmlns:a16="http://schemas.microsoft.com/office/drawing/2014/main" id="{ABCC9704-C77E-4833-8169-4BBBFC6C3E59}"/>
+                <a16:creationId xmlns:a16="http://schemas.microsoft.com/office/drawing/2014/main" id="{84D1B3F3-BFA8-434E-B9BA-398201E4C6E6}"/>
               </a:ext>
             </a:extLst>
           </p:cNvPr>
@@ -10899,7 +10957,7 @@
           <p:cNvPr id="8" name="">
             <a:extLst xmlns:a="http://schemas.openxmlformats.org/drawingml/2006/main">
               <a:ext uri="{FF2B5EF4-FFF2-40B4-BE49-F238E27FC236}">
-                <a16:creationId xmlns:a16="http://schemas.microsoft.com/office/drawing/2014/main" id="{4DE62D66-6C37-48C8-A0A5-3154BB960F82}"/>
+                <a16:creationId xmlns:a16="http://schemas.microsoft.com/office/drawing/2014/main" id="{5FFA7F00-007E-4654-BB35-230EE7041F72}"/>
               </a:ext>
             </a:extLst>
           </p:cNvPr>
@@ -11026,7 +11084,7 @@
           <p:cNvPr id="9" name="">
             <a:extLst xmlns:a="http://schemas.openxmlformats.org/drawingml/2006/main">
               <a:ext uri="{FF2B5EF4-FFF2-40B4-BE49-F238E27FC236}">
-                <a16:creationId xmlns:a16="http://schemas.microsoft.com/office/drawing/2014/main" id="{A5C6DA96-A36F-406B-9CF0-99AD011E3987}"/>
+                <a16:creationId xmlns:a16="http://schemas.microsoft.com/office/drawing/2014/main" id="{8A4B1657-FCB6-43AD-B9A0-F4308E11622B}"/>
               </a:ext>
             </a:extLst>
           </p:cNvPr>
@@ -11061,7 +11119,7 @@
           <p:cNvPr id="10" name="">
             <a:extLst xmlns:a="http://schemas.openxmlformats.org/drawingml/2006/main">
               <a:ext uri="{FF2B5EF4-FFF2-40B4-BE49-F238E27FC236}">
-                <a16:creationId xmlns:a16="http://schemas.microsoft.com/office/drawing/2014/main" id="{36719285-0097-4779-AA5F-53F02AD27961}"/>
+                <a16:creationId xmlns:a16="http://schemas.microsoft.com/office/drawing/2014/main" id="{D5354EE6-785E-4EA2-B4EA-1DC8BB2F7A98}"/>
               </a:ext>
             </a:extLst>
           </p:cNvPr>
@@ -11094,7 +11152,7 @@
           <p:cNvPr id="11" name="">
             <a:extLst xmlns:a="http://schemas.openxmlformats.org/drawingml/2006/main">
               <a:ext uri="{FF2B5EF4-FFF2-40B4-BE49-F238E27FC236}">
-                <a16:creationId xmlns:a16="http://schemas.microsoft.com/office/drawing/2014/main" id="{2D3B77A9-ACDC-4EAC-ACC6-5EC87492263E}"/>
+                <a16:creationId xmlns:a16="http://schemas.microsoft.com/office/drawing/2014/main" id="{5BD7EA8C-1509-4E90-95EA-3BDEEB7D0106}"/>
               </a:ext>
             </a:extLst>
           </p:cNvPr>
@@ -11152,7 +11210,7 @@
           <p:cNvPr id="12" name="">
             <a:extLst xmlns:a="http://schemas.openxmlformats.org/drawingml/2006/main">
               <a:ext uri="{FF2B5EF4-FFF2-40B4-BE49-F238E27FC236}">
-                <a16:creationId xmlns:a16="http://schemas.microsoft.com/office/drawing/2014/main" id="{3855A8BC-729D-4A3A-BDA5-743C0388157A}"/>
+                <a16:creationId xmlns:a16="http://schemas.microsoft.com/office/drawing/2014/main" id="{7D5521C5-F117-440E-964B-6A4E1E3F23EB}"/>
               </a:ext>
             </a:extLst>
           </p:cNvPr>
@@ -11279,7 +11337,7 @@
           <p:cNvPr id="13" name="">
             <a:extLst xmlns:a="http://schemas.openxmlformats.org/drawingml/2006/main">
               <a:ext uri="{FF2B5EF4-FFF2-40B4-BE49-F238E27FC236}">
-                <a16:creationId xmlns:a16="http://schemas.microsoft.com/office/drawing/2014/main" id="{130FAEC3-6CEA-46B2-941D-F3C47FE4FE2C}"/>
+                <a16:creationId xmlns:a16="http://schemas.microsoft.com/office/drawing/2014/main" id="{C1D12E6A-2F09-4834-876F-DC095090ADEC}"/>
               </a:ext>
             </a:extLst>
           </p:cNvPr>
@@ -11314,7 +11372,7 @@
           <p:cNvPr id="14" name="">
             <a:extLst xmlns:a="http://schemas.openxmlformats.org/drawingml/2006/main">
               <a:ext uri="{FF2B5EF4-FFF2-40B4-BE49-F238E27FC236}">
-                <a16:creationId xmlns:a16="http://schemas.microsoft.com/office/drawing/2014/main" id="{E32CFE1B-F56B-493F-AF44-7FB1F6CAC96F}"/>
+                <a16:creationId xmlns:a16="http://schemas.microsoft.com/office/drawing/2014/main" id="{D6EBB247-C17B-4DED-A15F-E6CC19C47C04}"/>
               </a:ext>
             </a:extLst>
           </p:cNvPr>
@@ -11347,7 +11405,7 @@
           <p:cNvPr id="15" name="">
             <a:extLst xmlns:a="http://schemas.openxmlformats.org/drawingml/2006/main">
               <a:ext uri="{FF2B5EF4-FFF2-40B4-BE49-F238E27FC236}">
-                <a16:creationId xmlns:a16="http://schemas.microsoft.com/office/drawing/2014/main" id="{1D089636-9233-48F2-BD4D-9C379DACA96D}"/>
+                <a16:creationId xmlns:a16="http://schemas.microsoft.com/office/drawing/2014/main" id="{A4D446E8-E197-4A2E-B915-B7F6D7E05329}"/>
               </a:ext>
             </a:extLst>
           </p:cNvPr>
@@ -11405,7 +11463,7 @@
           <p:cNvPr id="16" name="">
             <a:extLst xmlns:a="http://schemas.openxmlformats.org/drawingml/2006/main">
               <a:ext uri="{FF2B5EF4-FFF2-40B4-BE49-F238E27FC236}">
-                <a16:creationId xmlns:a16="http://schemas.microsoft.com/office/drawing/2014/main" id="{06F333DA-5540-4887-AD79-8FCCF405ADE2}"/>
+                <a16:creationId xmlns:a16="http://schemas.microsoft.com/office/drawing/2014/main" id="{17EA12E4-75B8-42D3-9FB3-325C9457AB9D}"/>
               </a:ext>
             </a:extLst>
           </p:cNvPr>
@@ -11532,7 +11590,7 @@
           <p:cNvPr id="17" name="">
             <a:extLst xmlns:a="http://schemas.openxmlformats.org/drawingml/2006/main">
               <a:ext uri="{FF2B5EF4-FFF2-40B4-BE49-F238E27FC236}">
-                <a16:creationId xmlns:a16="http://schemas.microsoft.com/office/drawing/2014/main" id="{ED20B5EA-4F86-497B-9435-7DB1626CF7D7}"/>
+                <a16:creationId xmlns:a16="http://schemas.microsoft.com/office/drawing/2014/main" id="{5F7702D4-685E-43AD-9F02-E4227E9D4D59}"/>
               </a:ext>
             </a:extLst>
           </p:cNvPr>
@@ -11588,7 +11646,7 @@
     </p:spTree>
     <p:extLst>
       <p:ext uri="{BB962C8B-B14F-4D97-AF65-F5344CB8AC3E}">
-        <p14:creationId xmlns:p14="http://schemas.microsoft.com/office/powerpoint/2010/main" val="1725364200"/>
+        <p14:creationId xmlns:p14="http://schemas.microsoft.com/office/powerpoint/2010/main" val="2135952078"/>
       </p:ext>
     </p:extLst>
   </p:cSld>

</xml_diff>